<commit_message>
Add the black book report, update the slide deck, remove the old poster pptx files
Black Book Report: fill in config.typ, write the six chapters (introduction,
literature survey, proposed system, implementation, results, conclusion),
abstract, acknowledgement, abbreviations, symbols, publications page,
bibliography, three appendices and the CO-PO mapping, and add the compiled
print, digital and spine PDFs.

Update LY Major Project PPT v4; remove the two poster pptx files.

Co-Authored-By: Claude Sonnet 5.5 <noreply@anthropic.com>
</commit_message>
<xml_diff>
--- a/Submission Documents/LY Major Project PPT v4.pptx
+++ b/Submission Documents/LY Major Project PPT v4.pptx
@@ -5,10 +5,10 @@
     <p:sldMasterId id="2147483659" r:id="rId1"/>
   </p:sldMasterIdLst>
   <p:notesMasterIdLst>
-    <p:notesMasterId r:id="rId22"/>
+    <p:notesMasterId r:id="rId23"/>
   </p:notesMasterIdLst>
   <p:handoutMasterIdLst>
-    <p:handoutMasterId r:id="rId23"/>
+    <p:handoutMasterId r:id="rId24"/>
   </p:handoutMasterIdLst>
   <p:sldIdLst>
     <p:sldId id="256" r:id="rId2"/>
@@ -16,22 +16,22 @@
     <p:sldId id="258" r:id="rId4"/>
     <p:sldId id="260" r:id="rId5"/>
     <p:sldId id="262" r:id="rId6"/>
-    <p:sldId id="281" r:id="rId28"/>
-    <p:sldId id="263" r:id="rId7"/>
-    <p:sldId id="259" r:id="rId8"/>
-    <p:sldId id="266" r:id="rId9"/>
-    <p:sldId id="268" r:id="rId10"/>
-    <p:sldId id="279" r:id="rId11"/>
-    <p:sldId id="264" r:id="rId12"/>
-    <p:sldId id="278" r:id="rId13"/>
-    <p:sldId id="275" r:id="rId14"/>
-    <p:sldId id="276" r:id="rId15"/>
-    <p:sldId id="277" r:id="rId16"/>
-    <p:sldId id="270" r:id="rId17"/>
-    <p:sldId id="271" r:id="rId18"/>
-    <p:sldId id="280" r:id="rId19"/>
-    <p:sldId id="273" r:id="rId20"/>
-    <p:sldId id="274" r:id="rId21"/>
+    <p:sldId id="281" r:id="rId7"/>
+    <p:sldId id="263" r:id="rId8"/>
+    <p:sldId id="259" r:id="rId9"/>
+    <p:sldId id="266" r:id="rId10"/>
+    <p:sldId id="268" r:id="rId11"/>
+    <p:sldId id="279" r:id="rId12"/>
+    <p:sldId id="264" r:id="rId13"/>
+    <p:sldId id="278" r:id="rId14"/>
+    <p:sldId id="275" r:id="rId15"/>
+    <p:sldId id="276" r:id="rId16"/>
+    <p:sldId id="277" r:id="rId17"/>
+    <p:sldId id="270" r:id="rId18"/>
+    <p:sldId id="271" r:id="rId19"/>
+    <p:sldId id="280" r:id="rId20"/>
+    <p:sldId id="273" r:id="rId21"/>
+    <p:sldId id="274" r:id="rId22"/>
   </p:sldIdLst>
   <p:sldSz cx="9144000" cy="5143500" type="screen16x9"/>
   <p:notesSz cx="6858000" cy="9144000"/>
@@ -368,7 +368,7 @@
           <a:p>
             <a:fld id="{1B35CFAD-E8E8-49C7-998E-4105CEA49942}" type="datetimeFigureOut">
               <a:rPr lang="en-IN" smtClean="0"/>
-              <a:t>23-09-2026</a:t>
+              <a:t>21-10-2026</a:t>
             </a:fld>
             <a:endParaRPr lang="en-IN"/>
           </a:p>
@@ -7615,6 +7615,498 @@
         <p:cNvPr id="1" name="Shape 53">
           <a:extLst>
             <a:ext uri="{FF2B5EF4-FFF2-40B4-BE49-F238E27FC236}">
+              <a16:creationId xmlns:a16="http://schemas.microsoft.com/office/drawing/2014/main" id="{9AC9D310-4864-5590-01EC-E271D4772333}"/>
+            </a:ext>
+          </a:extLst>
+        </p:cNvPr>
+        <p:cNvGrpSpPr/>
+        <p:nvPr/>
+      </p:nvGrpSpPr>
+      <p:grpSpPr>
+        <a:xfrm>
+          <a:off x="0" y="0"/>
+          <a:ext cx="0" cy="0"/>
+          <a:chOff x="0" y="0"/>
+          <a:chExt cx="0" cy="0"/>
+        </a:xfrm>
+      </p:grpSpPr>
+      <p:sp>
+        <p:nvSpPr>
+          <p:cNvPr id="2" name="TextBox 1">
+            <a:extLst>
+              <a:ext uri="{FF2B5EF4-FFF2-40B4-BE49-F238E27FC236}">
+                <a16:creationId xmlns:a16="http://schemas.microsoft.com/office/drawing/2014/main" id="{2486D6B1-412D-B9E1-2B60-E93887B2BB76}"/>
+              </a:ext>
+            </a:extLst>
+          </p:cNvPr>
+          <p:cNvSpPr txBox="1"/>
+          <p:nvPr/>
+        </p:nvSpPr>
+        <p:spPr>
+          <a:xfrm>
+            <a:off x="257175" y="4836100"/>
+            <a:ext cx="1343025" cy="276999"/>
+          </a:xfrm>
+          <a:prstGeom prst="rect">
+            <a:avLst/>
+          </a:prstGeom>
+          <a:noFill/>
+        </p:spPr>
+        <p:txBody>
+          <a:bodyPr wrap="square" rtlCol="0">
+            <a:spAutoFit/>
+          </a:bodyPr>
+          <a:lstStyle/>
+          <a:p>
+            <a:r>
+              <a:rPr lang="en-US" sz="1200" dirty="0">
+                <a:solidFill>
+                  <a:schemeClr val="bg1"/>
+                </a:solidFill>
+                <a:latin typeface="Times New Roman" panose="02020603050405020304" pitchFamily="18" charset="0"/>
+                <a:cs typeface="Times New Roman" panose="02020603050405020304" pitchFamily="18" charset="0"/>
+              </a:rPr>
+              <a:t>26/6/2023</a:t>
+            </a:r>
+          </a:p>
+        </p:txBody>
+      </p:sp>
+      <p:sp>
+        <p:nvSpPr>
+          <p:cNvPr id="15" name="Google Shape;97;p1">
+            <a:extLst>
+              <a:ext uri="{FF2B5EF4-FFF2-40B4-BE49-F238E27FC236}">
+                <a16:creationId xmlns:a16="http://schemas.microsoft.com/office/drawing/2014/main" id="{E47EBBBB-2103-581C-62AE-3A6C94A9BB61}"/>
+              </a:ext>
+            </a:extLst>
+          </p:cNvPr>
+          <p:cNvSpPr/>
+          <p:nvPr/>
+        </p:nvSpPr>
+        <p:spPr>
+          <a:xfrm>
+            <a:off x="8910006" y="1217600"/>
+            <a:ext cx="230488" cy="3941298"/>
+          </a:xfrm>
+          <a:prstGeom prst="rect">
+            <a:avLst/>
+          </a:prstGeom>
+          <a:solidFill>
+            <a:srgbClr val="C00000"/>
+          </a:solidFill>
+          <a:ln>
+            <a:noFill/>
+          </a:ln>
+        </p:spPr>
+        <p:txBody>
+          <a:bodyPr spcFirstLastPara="1" wrap="square" lIns="91425" tIns="45700" rIns="91425" bIns="45700" anchor="ctr" anchorCtr="0">
+            <a:noAutofit/>
+          </a:bodyPr>
+          <a:lstStyle/>
+          <a:p>
+            <a:pPr marL="0" marR="0" lvl="0" indent="0" algn="ctr" rtl="0">
+              <a:lnSpc>
+                <a:spcPct val="100000"/>
+              </a:lnSpc>
+              <a:spcBef>
+                <a:spcPts val="0"/>
+              </a:spcBef>
+              <a:spcAft>
+                <a:spcPts val="0"/>
+              </a:spcAft>
+              <a:buClr>
+                <a:srgbClr val="000000"/>
+              </a:buClr>
+              <a:buSzPts val="2493"/>
+              <a:buFont typeface="Arial"/>
+              <a:buNone/>
+            </a:pPr>
+            <a:endParaRPr sz="2493" b="0" i="0" u="none" strike="noStrike" cap="none">
+              <a:solidFill>
+                <a:schemeClr val="lt1"/>
+              </a:solidFill>
+              <a:latin typeface="Arial"/>
+              <a:ea typeface="Arial"/>
+              <a:cs typeface="Arial"/>
+              <a:sym typeface="Arial"/>
+            </a:endParaRPr>
+          </a:p>
+        </p:txBody>
+      </p:sp>
+      <p:sp>
+        <p:nvSpPr>
+          <p:cNvPr id="16" name="Google Shape;97;p1">
+            <a:extLst>
+              <a:ext uri="{FF2B5EF4-FFF2-40B4-BE49-F238E27FC236}">
+                <a16:creationId xmlns:a16="http://schemas.microsoft.com/office/drawing/2014/main" id="{4A189411-E6B6-3AD2-F9D7-14323DAF38C3}"/>
+              </a:ext>
+            </a:extLst>
+          </p:cNvPr>
+          <p:cNvSpPr/>
+          <p:nvPr/>
+        </p:nvSpPr>
+        <p:spPr>
+          <a:xfrm>
+            <a:off x="2105025" y="4836100"/>
+            <a:ext cx="6807206" cy="322797"/>
+          </a:xfrm>
+          <a:prstGeom prst="rect">
+            <a:avLst/>
+          </a:prstGeom>
+          <a:solidFill>
+            <a:srgbClr val="C00000"/>
+          </a:solidFill>
+          <a:ln>
+            <a:noFill/>
+          </a:ln>
+        </p:spPr>
+        <p:txBody>
+          <a:bodyPr spcFirstLastPara="1" wrap="square" lIns="91425" tIns="45700" rIns="91425" bIns="45700" anchor="ctr" anchorCtr="0">
+            <a:noAutofit/>
+          </a:bodyPr>
+          <a:lstStyle/>
+          <a:p>
+            <a:pPr marL="0" marR="0" lvl="0" indent="0" algn="ctr" rtl="0">
+              <a:lnSpc>
+                <a:spcPct val="100000"/>
+              </a:lnSpc>
+              <a:spcBef>
+                <a:spcPts val="0"/>
+              </a:spcBef>
+              <a:spcAft>
+                <a:spcPts val="0"/>
+              </a:spcAft>
+              <a:buClr>
+                <a:srgbClr val="000000"/>
+              </a:buClr>
+              <a:buSzPts val="2493"/>
+              <a:buFont typeface="Arial"/>
+              <a:buNone/>
+            </a:pPr>
+            <a:endParaRPr sz="2493" b="0" i="0" u="none" strike="noStrike" cap="none">
+              <a:solidFill>
+                <a:schemeClr val="lt1"/>
+              </a:solidFill>
+              <a:latin typeface="Arial"/>
+              <a:ea typeface="Arial"/>
+              <a:cs typeface="Arial"/>
+              <a:sym typeface="Arial"/>
+            </a:endParaRPr>
+          </a:p>
+        </p:txBody>
+      </p:sp>
+      <p:sp>
+        <p:nvSpPr>
+          <p:cNvPr id="17" name="Rectangle 16">
+            <a:extLst>
+              <a:ext uri="{FF2B5EF4-FFF2-40B4-BE49-F238E27FC236}">
+                <a16:creationId xmlns:a16="http://schemas.microsoft.com/office/drawing/2014/main" id="{2B64D24D-6253-C5A7-684B-84D557D646E1}"/>
+              </a:ext>
+            </a:extLst>
+          </p:cNvPr>
+          <p:cNvSpPr/>
+          <p:nvPr/>
+        </p:nvSpPr>
+        <p:spPr>
+          <a:xfrm>
+            <a:off x="0" y="4836100"/>
+            <a:ext cx="2105025" cy="322798"/>
+          </a:xfrm>
+          <a:prstGeom prst="rect">
+            <a:avLst/>
+          </a:prstGeom>
+          <a:solidFill>
+            <a:srgbClr val="FF0000"/>
+          </a:solidFill>
+          <a:ln>
+            <a:noFill/>
+          </a:ln>
+        </p:spPr>
+        <p:style>
+          <a:lnRef idx="2">
+            <a:schemeClr val="accent1">
+              <a:shade val="50000"/>
+            </a:schemeClr>
+          </a:lnRef>
+          <a:fillRef idx="1">
+            <a:schemeClr val="accent1"/>
+          </a:fillRef>
+          <a:effectRef idx="0">
+            <a:schemeClr val="accent1"/>
+          </a:effectRef>
+          <a:fontRef idx="minor">
+            <a:schemeClr val="lt1"/>
+          </a:fontRef>
+        </p:style>
+        <p:txBody>
+          <a:bodyPr rtlCol="0" anchor="ctr"/>
+          <a:lstStyle/>
+          <a:p>
+            <a:endParaRPr lang="en-US" sz="1200" dirty="0">
+              <a:latin typeface="Times New Roman" pitchFamily="18" charset="0"/>
+              <a:cs typeface="Times New Roman" pitchFamily="18" charset="0"/>
+            </a:endParaRPr>
+          </a:p>
+        </p:txBody>
+      </p:sp>
+      <p:pic>
+        <p:nvPicPr>
+          <p:cNvPr id="8" name="Picture 2">
+            <a:extLst>
+              <a:ext uri="{FF2B5EF4-FFF2-40B4-BE49-F238E27FC236}">
+                <a16:creationId xmlns:a16="http://schemas.microsoft.com/office/drawing/2014/main" id="{0F8827DB-DDB0-6DA0-5EBE-F1CDA01C8DAE}"/>
+              </a:ext>
+            </a:extLst>
+          </p:cNvPr>
+          <p:cNvPicPr>
+            <a:picLocks noChangeAspect="1" noChangeArrowheads="1"/>
+          </p:cNvPicPr>
+          <p:nvPr/>
+        </p:nvPicPr>
+        <p:blipFill>
+          <a:blip r:embed="rId3">
+            <a:extLst>
+              <a:ext uri="{28A0092B-C50C-407E-A947-70E740481C1C}">
+                <a14:useLocalDpi xmlns:a14="http://schemas.microsoft.com/office/drawing/2010/main" val="0"/>
+              </a:ext>
+            </a:extLst>
+          </a:blip>
+          <a:srcRect/>
+          <a:stretch>
+            <a:fillRect/>
+          </a:stretch>
+        </p:blipFill>
+        <p:spPr bwMode="auto">
+          <a:xfrm>
+            <a:off x="0" y="0"/>
+            <a:ext cx="9140493" cy="1332186"/>
+          </a:xfrm>
+          <a:prstGeom prst="rect">
+            <a:avLst/>
+          </a:prstGeom>
+          <a:noFill/>
+          <a:ln>
+            <a:noFill/>
+          </a:ln>
+          <a:effectLst/>
+          <a:extLst>
+            <a:ext uri="{909E8E84-426E-40DD-AFC4-6F175D3DCCD1}">
+              <a14:hiddenFill xmlns:a14="http://schemas.microsoft.com/office/drawing/2010/main">
+                <a:solidFill>
+                  <a:schemeClr val="accent1"/>
+                </a:solidFill>
+              </a14:hiddenFill>
+            </a:ext>
+            <a:ext uri="{91240B29-F687-4F45-9708-019B960494DF}">
+              <a14:hiddenLine xmlns:a14="http://schemas.microsoft.com/office/drawing/2010/main" w="9525">
+                <a:solidFill>
+                  <a:schemeClr val="tx1"/>
+                </a:solidFill>
+                <a:miter lim="800000"/>
+                <a:headEnd/>
+                <a:tailEnd/>
+              </a14:hiddenLine>
+            </a:ext>
+            <a:ext uri="{AF507438-7753-43E0-B8FC-AC1667EBCBE1}">
+              <a14:hiddenEffects xmlns:a14="http://schemas.microsoft.com/office/drawing/2010/main">
+                <a:effectLst>
+                  <a:outerShdw dist="35921" dir="2700000" algn="ctr" rotWithShape="0">
+                    <a:schemeClr val="bg2"/>
+                  </a:outerShdw>
+                </a:effectLst>
+              </a14:hiddenEffects>
+            </a:ext>
+          </a:extLst>
+        </p:spPr>
+      </p:pic>
+      <p:sp>
+        <p:nvSpPr>
+          <p:cNvPr id="7" name="Google Shape;59;p13">
+            <a:extLst>
+              <a:ext uri="{FF2B5EF4-FFF2-40B4-BE49-F238E27FC236}">
+                <a16:creationId xmlns:a16="http://schemas.microsoft.com/office/drawing/2014/main" id="{86719920-E6A2-6F3A-5ED0-756DB9F14FA5}"/>
+              </a:ext>
+            </a:extLst>
+          </p:cNvPr>
+          <p:cNvSpPr txBox="1"/>
+          <p:nvPr/>
+        </p:nvSpPr>
+        <p:spPr>
+          <a:xfrm>
+            <a:off x="61475" y="4508750"/>
+            <a:ext cx="8678700" cy="323135"/>
+          </a:xfrm>
+          <a:prstGeom prst="rect">
+            <a:avLst/>
+          </a:prstGeom>
+          <a:noFill/>
+          <a:ln>
+            <a:noFill/>
+          </a:ln>
+        </p:spPr>
+        <p:txBody>
+          <a:bodyPr spcFirstLastPara="1" wrap="square" lIns="91425" tIns="91425" rIns="91425" bIns="91425" anchor="t" anchorCtr="0">
+            <a:spAutoFit/>
+          </a:bodyPr>
+          <a:lstStyle/>
+          <a:p>
+            <a:pPr marL="0" lvl="0" indent="0" rtl="0">
+              <a:spcBef>
+                <a:spcPts val="0"/>
+              </a:spcBef>
+              <a:spcAft>
+                <a:spcPts val="0"/>
+              </a:spcAft>
+              <a:buNone/>
+            </a:pPr>
+            <a:r>
+              <a:rPr lang="en" sz="900" dirty="0">
+                <a:latin typeface="Times New Roman"/>
+                <a:ea typeface="Times New Roman"/>
+                <a:cs typeface="Times New Roman"/>
+                <a:sym typeface="Times New Roman"/>
+              </a:rPr>
+              <a:t>                                                                                                        </a:t>
+            </a:r>
+            <a:r>
+              <a:rPr lang="en" sz="900" i="1" dirty="0">
+                <a:latin typeface="Times New Roman"/>
+                <a:ea typeface="Times New Roman"/>
+                <a:cs typeface="Times New Roman"/>
+                <a:sym typeface="Times New Roman"/>
+              </a:rPr>
+              <a:t>Department of AI-DS, K J Somaiya Institute of Technology, Sion, Mumbai </a:t>
+            </a:r>
+            <a:endParaRPr sz="900" i="1" dirty="0">
+              <a:latin typeface="Times New Roman"/>
+              <a:ea typeface="Times New Roman"/>
+              <a:cs typeface="Times New Roman"/>
+              <a:sym typeface="Times New Roman"/>
+            </a:endParaRPr>
+          </a:p>
+        </p:txBody>
+      </p:sp>
+      <p:sp>
+        <p:nvSpPr>
+          <p:cNvPr id="5" name="Google Shape;62;p13">
+            <a:extLst>
+              <a:ext uri="{FF2B5EF4-FFF2-40B4-BE49-F238E27FC236}">
+                <a16:creationId xmlns:a16="http://schemas.microsoft.com/office/drawing/2014/main" id="{4F3B70C8-3900-6C02-0754-2639E651B4B2}"/>
+              </a:ext>
+            </a:extLst>
+          </p:cNvPr>
+          <p:cNvSpPr txBox="1"/>
+          <p:nvPr/>
+        </p:nvSpPr>
+        <p:spPr>
+          <a:xfrm>
+            <a:off x="300000" y="1300000"/>
+            <a:ext cx="8500000" cy="420000"/>
+          </a:xfrm>
+          <a:prstGeom prst="rect">
+            <a:avLst/>
+          </a:prstGeom>
+          <a:noFill/>
+          <a:ln>
+            <a:noFill/>
+          </a:ln>
+        </p:spPr>
+        <p:txBody>
+          <a:bodyPr spcFirstLastPara="1" wrap="square" lIns="91425" tIns="45700" rIns="91425" bIns="45700" anchor="t" anchorCtr="0">
+            <a:spAutoFit/>
+          </a:bodyPr>
+          <a:lstStyle/>
+          <a:p>
+            <a:pPr marL="0" marR="0" lvl="0" indent="0" algn="l" rtl="0">
+              <a:spcBef>
+                <a:spcPts val="0"/>
+              </a:spcBef>
+              <a:spcAft>
+                <a:spcPts val="0"/>
+              </a:spcAft>
+              <a:buNone/>
+            </a:pPr>
+            <a:r>
+              <a:rPr lang="en-IN" sz="2000" b="1" dirty="0">
+                <a:solidFill>
+                  <a:srgbClr val="C00000"/>
+                </a:solidFill>
+                <a:latin typeface="Times New Roman"/>
+                <a:ea typeface="Times New Roman"/>
+                <a:cs typeface="Times New Roman"/>
+                <a:sym typeface="Times New Roman"/>
+              </a:rPr>
+              <a:t>Proposed System Implementation</a:t>
+            </a:r>
+            <a:endParaRPr sz="1800" dirty="0">
+              <a:solidFill>
+                <a:srgbClr val="000000"/>
+              </a:solidFill>
+              <a:latin typeface="Times New Roman"/>
+              <a:ea typeface="Times New Roman"/>
+              <a:cs typeface="Times New Roman"/>
+              <a:sym typeface="Times New Roman"/>
+            </a:endParaRPr>
+          </a:p>
+        </p:txBody>
+      </p:sp>
+      <p:pic>
+        <p:nvPicPr>
+          <p:cNvPr id="9" name="Graphic 8">
+            <a:extLst>
+              <a:ext uri="{FF2B5EF4-FFF2-40B4-BE49-F238E27FC236}">
+                <a16:creationId xmlns:a16="http://schemas.microsoft.com/office/drawing/2014/main" id="{6BEE846D-440B-1C8A-C0EF-EAD5518C6FF7}"/>
+              </a:ext>
+            </a:extLst>
+          </p:cNvPr>
+          <p:cNvPicPr>
+            <a:picLocks noChangeAspect="1"/>
+          </p:cNvPicPr>
+          <p:nvPr/>
+        </p:nvPicPr>
+        <p:blipFill>
+          <a:blip>
+            <a:extLst>
+              <a:ext uri="{96DAC541-7B7A-43D3-8B79-37D633B846F1}">
+                <asvg:svgBlip xmlns:asvg="http://schemas.microsoft.com/office/drawing/2016/SVG/main" r:embed="rId4"/>
+              </a:ext>
+            </a:extLst>
+          </a:blip>
+          <a:stretch>
+            <a:fillRect/>
+          </a:stretch>
+        </p:blipFill>
+        <p:spPr>
+          <a:xfrm>
+            <a:off x="300000" y="1799689"/>
+            <a:ext cx="8379901" cy="2113284"/>
+          </a:xfrm>
+          <a:prstGeom prst="rect">
+            <a:avLst/>
+          </a:prstGeom>
+        </p:spPr>
+      </p:pic>
+    </p:spTree>
+    <p:extLst>
+      <p:ext uri="{BB962C8B-B14F-4D97-AF65-F5344CB8AC3E}">
+        <p14:creationId xmlns:p14="http://schemas.microsoft.com/office/powerpoint/2010/main" val="565558269"/>
+      </p:ext>
+    </p:extLst>
+  </p:cSld>
+  <p:clrMapOvr>
+    <a:masterClrMapping/>
+  </p:clrMapOvr>
+</p:sld>
+</file>
+
+<file path=ppt/slides/slide11.xml><?xml version="1.0" encoding="utf-8"?>
+<p:sld xmlns:a="http://schemas.openxmlformats.org/drawingml/2006/main" xmlns:r="http://schemas.openxmlformats.org/officeDocument/2006/relationships" xmlns:p="http://schemas.openxmlformats.org/presentationml/2006/main">
+  <p:cSld>
+    <p:spTree>
+      <p:nvGrpSpPr>
+        <p:cNvPr id="1" name="Shape 53">
+          <a:extLst>
+            <a:ext uri="{FF2B5EF4-FFF2-40B4-BE49-F238E27FC236}">
               <a16:creationId xmlns:a16="http://schemas.microsoft.com/office/drawing/2014/main" id="{F595A196-97FE-9954-F1EC-82965F4DB7DE}"/>
             </a:ext>
           </a:extLst>
@@ -8029,7 +8521,7 @@
 </p:sld>
 </file>
 
-<file path=ppt/slides/slide11.xml><?xml version="1.0" encoding="utf-8"?>
+<file path=ppt/slides/slide12.xml><?xml version="1.0" encoding="utf-8"?>
 <p:sld xmlns:a="http://schemas.openxmlformats.org/drawingml/2006/main" xmlns:r="http://schemas.openxmlformats.org/officeDocument/2006/relationships" xmlns:p="http://schemas.openxmlformats.org/presentationml/2006/main">
   <p:cSld>
     <p:spTree>
@@ -8907,7 +9399,7 @@
 </p:sld>
 </file>
 
-<file path=ppt/slides/slide12.xml><?xml version="1.0" encoding="utf-8"?>
+<file path=ppt/slides/slide13.xml><?xml version="1.0" encoding="utf-8"?>
 <p:sld xmlns:a="http://schemas.openxmlformats.org/drawingml/2006/main" xmlns:r="http://schemas.openxmlformats.org/officeDocument/2006/relationships" xmlns:p="http://schemas.openxmlformats.org/presentationml/2006/main">
   <p:cSld>
     <p:spTree>
@@ -9963,7 +10455,7 @@
 </p:sld>
 </file>
 
-<file path=ppt/slides/slide13.xml><?xml version="1.0" encoding="utf-8"?>
+<file path=ppt/slides/slide14.xml><?xml version="1.0" encoding="utf-8"?>
 <p:sld xmlns:a="http://schemas.openxmlformats.org/drawingml/2006/main" xmlns:r="http://schemas.openxmlformats.org/officeDocument/2006/relationships" xmlns:p="http://schemas.openxmlformats.org/presentationml/2006/main">
   <p:cSld>
     <p:spTree>
@@ -10133,7 +10625,7 @@
 </p:sld>
 </file>
 
-<file path=ppt/slides/slide14.xml><?xml version="1.0" encoding="utf-8"?>
+<file path=ppt/slides/slide15.xml><?xml version="1.0" encoding="utf-8"?>
 <p:sld xmlns:a="http://schemas.openxmlformats.org/drawingml/2006/main" xmlns:r="http://schemas.openxmlformats.org/officeDocument/2006/relationships" xmlns:p="http://schemas.openxmlformats.org/presentationml/2006/main">
   <p:cSld>
     <p:spTree>
@@ -10270,7 +10762,7 @@
 </p:sld>
 </file>
 
-<file path=ppt/slides/slide15.xml><?xml version="1.0" encoding="utf-8"?>
+<file path=ppt/slides/slide16.xml><?xml version="1.0" encoding="utf-8"?>
 <p:sld xmlns:a="http://schemas.openxmlformats.org/drawingml/2006/main" xmlns:r="http://schemas.openxmlformats.org/officeDocument/2006/relationships" xmlns:p="http://schemas.openxmlformats.org/presentationml/2006/main">
   <p:cSld>
     <p:spTree>
@@ -10407,7 +10899,7 @@
 </p:sld>
 </file>
 
-<file path=ppt/slides/slide16.xml><?xml version="1.0" encoding="utf-8"?>
+<file path=ppt/slides/slide17.xml><?xml version="1.0" encoding="utf-8"?>
 <p:sld xmlns:a="http://schemas.openxmlformats.org/drawingml/2006/main" xmlns:r="http://schemas.openxmlformats.org/officeDocument/2006/relationships" xmlns:p="http://schemas.openxmlformats.org/presentationml/2006/main">
   <p:cSld>
     <p:spTree>
@@ -11320,7 +11812,7 @@
 </p:sld>
 </file>
 
-<file path=ppt/slides/slide17.xml><?xml version="1.0" encoding="utf-8"?>
+<file path=ppt/slides/slide18.xml><?xml version="1.0" encoding="utf-8"?>
 <p:sld xmlns:a="http://schemas.openxmlformats.org/drawingml/2006/main" xmlns:r="http://schemas.openxmlformats.org/officeDocument/2006/relationships" xmlns:p="http://schemas.openxmlformats.org/presentationml/2006/main">
   <p:cSld>
     <p:spTree>
@@ -11870,7 +12362,7 @@
 </p:sld>
 </file>
 
-<file path=ppt/slides/slide18.xml><?xml version="1.0" encoding="utf-8"?>
+<file path=ppt/slides/slide19.xml><?xml version="1.0" encoding="utf-8"?>
 <p:sld xmlns:a="http://schemas.openxmlformats.org/drawingml/2006/main" xmlns:r="http://schemas.openxmlformats.org/officeDocument/2006/relationships" xmlns:p="http://schemas.openxmlformats.org/presentationml/2006/main">
   <p:cSld>
     <p:spTree>
@@ -12408,742 +12900,6 @@
     <p:extLst>
       <p:ext uri="{BB962C8B-B14F-4D97-AF65-F5344CB8AC3E}">
         <p14:creationId xmlns:p14="http://schemas.microsoft.com/office/powerpoint/2010/main" val="2927283450"/>
-      </p:ext>
-    </p:extLst>
-  </p:cSld>
-  <p:clrMapOvr>
-    <a:masterClrMapping/>
-  </p:clrMapOvr>
-</p:sld>
-</file>
-
-<file path=ppt/slides/slide19.xml><?xml version="1.0" encoding="utf-8"?>
-<p:sld xmlns:a="http://schemas.openxmlformats.org/drawingml/2006/main" xmlns:r="http://schemas.openxmlformats.org/officeDocument/2006/relationships" xmlns:p="http://schemas.openxmlformats.org/presentationml/2006/main">
-  <p:cSld>
-    <p:spTree>
-      <p:nvGrpSpPr>
-        <p:cNvPr id="1" name="Shape 53">
-          <a:extLst>
-            <a:ext uri="{FF2B5EF4-FFF2-40B4-BE49-F238E27FC236}">
-              <a16:creationId xmlns:a16="http://schemas.microsoft.com/office/drawing/2014/main" id="{2DDF6233-2213-9DE7-0384-FD2E5E619399}"/>
-            </a:ext>
-          </a:extLst>
-        </p:cNvPr>
-        <p:cNvGrpSpPr/>
-        <p:nvPr/>
-      </p:nvGrpSpPr>
-      <p:grpSpPr>
-        <a:xfrm>
-          <a:off x="0" y="0"/>
-          <a:ext cx="0" cy="0"/>
-          <a:chOff x="0" y="0"/>
-          <a:chExt cx="0" cy="0"/>
-        </a:xfrm>
-      </p:grpSpPr>
-      <p:sp>
-        <p:nvSpPr>
-          <p:cNvPr id="2" name="TextBox 1">
-            <a:extLst>
-              <a:ext uri="{FF2B5EF4-FFF2-40B4-BE49-F238E27FC236}">
-                <a16:creationId xmlns:a16="http://schemas.microsoft.com/office/drawing/2014/main" id="{B5EF41DB-BA66-B530-3083-2D5827F8E522}"/>
-              </a:ext>
-            </a:extLst>
-          </p:cNvPr>
-          <p:cNvSpPr txBox="1"/>
-          <p:nvPr/>
-        </p:nvSpPr>
-        <p:spPr>
-          <a:xfrm>
-            <a:off x="257175" y="4836100"/>
-            <a:ext cx="1343025" cy="276999"/>
-          </a:xfrm>
-          <a:prstGeom prst="rect">
-            <a:avLst/>
-          </a:prstGeom>
-          <a:noFill/>
-        </p:spPr>
-        <p:txBody>
-          <a:bodyPr wrap="square" rtlCol="0">
-            <a:spAutoFit/>
-          </a:bodyPr>
-          <a:lstStyle/>
-          <a:p>
-            <a:r>
-              <a:rPr lang="en-US" sz="1200" dirty="0">
-                <a:solidFill>
-                  <a:schemeClr val="bg1"/>
-                </a:solidFill>
-                <a:latin typeface="Times New Roman" panose="02020603050405020304" pitchFamily="18" charset="0"/>
-                <a:cs typeface="Times New Roman" panose="02020603050405020304" pitchFamily="18" charset="0"/>
-              </a:rPr>
-              <a:t>26/6/2023</a:t>
-            </a:r>
-          </a:p>
-        </p:txBody>
-      </p:sp>
-      <p:sp>
-        <p:nvSpPr>
-          <p:cNvPr id="15" name="Google Shape;97;p1">
-            <a:extLst>
-              <a:ext uri="{FF2B5EF4-FFF2-40B4-BE49-F238E27FC236}">
-                <a16:creationId xmlns:a16="http://schemas.microsoft.com/office/drawing/2014/main" id="{B0F60ECF-C2DE-ECD9-BE9F-4561339DA83B}"/>
-              </a:ext>
-            </a:extLst>
-          </p:cNvPr>
-          <p:cNvSpPr/>
-          <p:nvPr/>
-        </p:nvSpPr>
-        <p:spPr>
-          <a:xfrm>
-            <a:off x="8910006" y="1217600"/>
-            <a:ext cx="230488" cy="3941298"/>
-          </a:xfrm>
-          <a:prstGeom prst="rect">
-            <a:avLst/>
-          </a:prstGeom>
-          <a:solidFill>
-            <a:srgbClr val="C00000"/>
-          </a:solidFill>
-          <a:ln>
-            <a:noFill/>
-          </a:ln>
-        </p:spPr>
-        <p:txBody>
-          <a:bodyPr spcFirstLastPara="1" wrap="square" lIns="91425" tIns="45700" rIns="91425" bIns="45700" anchor="ctr" anchorCtr="0">
-            <a:noAutofit/>
-          </a:bodyPr>
-          <a:lstStyle/>
-          <a:p>
-            <a:pPr marL="0" marR="0" lvl="0" indent="0" algn="ctr" rtl="0">
-              <a:lnSpc>
-                <a:spcPct val="100000"/>
-              </a:lnSpc>
-              <a:spcBef>
-                <a:spcPts val="0"/>
-              </a:spcBef>
-              <a:spcAft>
-                <a:spcPts val="0"/>
-              </a:spcAft>
-              <a:buClr>
-                <a:srgbClr val="000000"/>
-              </a:buClr>
-              <a:buSzPts val="2493"/>
-              <a:buFont typeface="Arial"/>
-              <a:buNone/>
-            </a:pPr>
-            <a:endParaRPr sz="2493" b="0" i="0" u="none" strike="noStrike" cap="none">
-              <a:solidFill>
-                <a:schemeClr val="lt1"/>
-              </a:solidFill>
-              <a:latin typeface="Arial"/>
-              <a:ea typeface="Arial"/>
-              <a:cs typeface="Arial"/>
-              <a:sym typeface="Arial"/>
-            </a:endParaRPr>
-          </a:p>
-        </p:txBody>
-      </p:sp>
-      <p:sp>
-        <p:nvSpPr>
-          <p:cNvPr id="16" name="Google Shape;97;p1">
-            <a:extLst>
-              <a:ext uri="{FF2B5EF4-FFF2-40B4-BE49-F238E27FC236}">
-                <a16:creationId xmlns:a16="http://schemas.microsoft.com/office/drawing/2014/main" id="{9E889681-3007-B447-1F1F-CB57E44079C2}"/>
-              </a:ext>
-            </a:extLst>
-          </p:cNvPr>
-          <p:cNvSpPr/>
-          <p:nvPr/>
-        </p:nvSpPr>
-        <p:spPr>
-          <a:xfrm>
-            <a:off x="2105025" y="4836100"/>
-            <a:ext cx="6807206" cy="322797"/>
-          </a:xfrm>
-          <a:prstGeom prst="rect">
-            <a:avLst/>
-          </a:prstGeom>
-          <a:solidFill>
-            <a:srgbClr val="C00000"/>
-          </a:solidFill>
-          <a:ln>
-            <a:noFill/>
-          </a:ln>
-        </p:spPr>
-        <p:txBody>
-          <a:bodyPr spcFirstLastPara="1" wrap="square" lIns="91425" tIns="45700" rIns="91425" bIns="45700" anchor="ctr" anchorCtr="0">
-            <a:noAutofit/>
-          </a:bodyPr>
-          <a:lstStyle/>
-          <a:p>
-            <a:pPr marL="0" marR="0" lvl="0" indent="0" algn="ctr" rtl="0">
-              <a:lnSpc>
-                <a:spcPct val="100000"/>
-              </a:lnSpc>
-              <a:spcBef>
-                <a:spcPts val="0"/>
-              </a:spcBef>
-              <a:spcAft>
-                <a:spcPts val="0"/>
-              </a:spcAft>
-              <a:buClr>
-                <a:srgbClr val="000000"/>
-              </a:buClr>
-              <a:buSzPts val="2493"/>
-              <a:buFont typeface="Arial"/>
-              <a:buNone/>
-            </a:pPr>
-            <a:endParaRPr sz="2493" b="0" i="0" u="none" strike="noStrike" cap="none">
-              <a:solidFill>
-                <a:schemeClr val="lt1"/>
-              </a:solidFill>
-              <a:latin typeface="Arial"/>
-              <a:ea typeface="Arial"/>
-              <a:cs typeface="Arial"/>
-              <a:sym typeface="Arial"/>
-            </a:endParaRPr>
-          </a:p>
-        </p:txBody>
-      </p:sp>
-      <p:sp>
-        <p:nvSpPr>
-          <p:cNvPr id="17" name="Rectangle 16">
-            <a:extLst>
-              <a:ext uri="{FF2B5EF4-FFF2-40B4-BE49-F238E27FC236}">
-                <a16:creationId xmlns:a16="http://schemas.microsoft.com/office/drawing/2014/main" id="{685EDB76-054D-6747-B086-4FC3E0155731}"/>
-              </a:ext>
-            </a:extLst>
-          </p:cNvPr>
-          <p:cNvSpPr/>
-          <p:nvPr/>
-        </p:nvSpPr>
-        <p:spPr>
-          <a:xfrm>
-            <a:off x="0" y="4836100"/>
-            <a:ext cx="2105025" cy="322798"/>
-          </a:xfrm>
-          <a:prstGeom prst="rect">
-            <a:avLst/>
-          </a:prstGeom>
-          <a:solidFill>
-            <a:srgbClr val="FF0000"/>
-          </a:solidFill>
-          <a:ln>
-            <a:noFill/>
-          </a:ln>
-        </p:spPr>
-        <p:style>
-          <a:lnRef idx="2">
-            <a:schemeClr val="accent1">
-              <a:shade val="50000"/>
-            </a:schemeClr>
-          </a:lnRef>
-          <a:fillRef idx="1">
-            <a:schemeClr val="accent1"/>
-          </a:fillRef>
-          <a:effectRef idx="0">
-            <a:schemeClr val="accent1"/>
-          </a:effectRef>
-          <a:fontRef idx="minor">
-            <a:schemeClr val="lt1"/>
-          </a:fontRef>
-        </p:style>
-        <p:txBody>
-          <a:bodyPr rtlCol="0" anchor="ctr"/>
-          <a:lstStyle/>
-          <a:p>
-            <a:endParaRPr lang="en-US" sz="1200" dirty="0">
-              <a:latin typeface="Times New Roman" pitchFamily="18" charset="0"/>
-              <a:cs typeface="Times New Roman" pitchFamily="18" charset="0"/>
-            </a:endParaRPr>
-          </a:p>
-        </p:txBody>
-      </p:sp>
-      <p:pic>
-        <p:nvPicPr>
-          <p:cNvPr id="8" name="Picture 2">
-            <a:extLst>
-              <a:ext uri="{FF2B5EF4-FFF2-40B4-BE49-F238E27FC236}">
-                <a16:creationId xmlns:a16="http://schemas.microsoft.com/office/drawing/2014/main" id="{7264FC4E-3387-E874-ECFE-049C3FA8DB33}"/>
-              </a:ext>
-            </a:extLst>
-          </p:cNvPr>
-          <p:cNvPicPr>
-            <a:picLocks noChangeAspect="1" noChangeArrowheads="1"/>
-          </p:cNvPicPr>
-          <p:nvPr/>
-        </p:nvPicPr>
-        <p:blipFill>
-          <a:blip r:embed="rId3">
-            <a:extLst>
-              <a:ext uri="{28A0092B-C50C-407E-A947-70E740481C1C}">
-                <a14:useLocalDpi xmlns:a14="http://schemas.microsoft.com/office/drawing/2010/main" val="0"/>
-              </a:ext>
-            </a:extLst>
-          </a:blip>
-          <a:srcRect/>
-          <a:stretch>
-            <a:fillRect/>
-          </a:stretch>
-        </p:blipFill>
-        <p:spPr bwMode="auto">
-          <a:xfrm>
-            <a:off x="0" y="0"/>
-            <a:ext cx="9140493" cy="1332186"/>
-          </a:xfrm>
-          <a:prstGeom prst="rect">
-            <a:avLst/>
-          </a:prstGeom>
-          <a:noFill/>
-          <a:ln>
-            <a:noFill/>
-          </a:ln>
-          <a:effectLst/>
-          <a:extLst>
-            <a:ext uri="{909E8E84-426E-40DD-AFC4-6F175D3DCCD1}">
-              <a14:hiddenFill xmlns:a14="http://schemas.microsoft.com/office/drawing/2010/main">
-                <a:solidFill>
-                  <a:schemeClr val="accent1"/>
-                </a:solidFill>
-              </a14:hiddenFill>
-            </a:ext>
-            <a:ext uri="{91240B29-F687-4F45-9708-019B960494DF}">
-              <a14:hiddenLine xmlns:a14="http://schemas.microsoft.com/office/drawing/2010/main" w="9525">
-                <a:solidFill>
-                  <a:schemeClr val="tx1"/>
-                </a:solidFill>
-                <a:miter lim="800000"/>
-                <a:headEnd/>
-                <a:tailEnd/>
-              </a14:hiddenLine>
-            </a:ext>
-            <a:ext uri="{AF507438-7753-43E0-B8FC-AC1667EBCBE1}">
-              <a14:hiddenEffects xmlns:a14="http://schemas.microsoft.com/office/drawing/2010/main">
-                <a:effectLst>
-                  <a:outerShdw dist="35921" dir="2700000" algn="ctr" rotWithShape="0">
-                    <a:schemeClr val="bg2"/>
-                  </a:outerShdw>
-                </a:effectLst>
-              </a14:hiddenEffects>
-            </a:ext>
-          </a:extLst>
-        </p:spPr>
-      </p:pic>
-      <p:sp>
-        <p:nvSpPr>
-          <p:cNvPr id="7" name="Google Shape;59;p13">
-            <a:extLst>
-              <a:ext uri="{FF2B5EF4-FFF2-40B4-BE49-F238E27FC236}">
-                <a16:creationId xmlns:a16="http://schemas.microsoft.com/office/drawing/2014/main" id="{B99E41EF-F00B-22A5-7155-796E4FC78B49}"/>
-              </a:ext>
-            </a:extLst>
-          </p:cNvPr>
-          <p:cNvSpPr txBox="1"/>
-          <p:nvPr/>
-        </p:nvSpPr>
-        <p:spPr>
-          <a:xfrm>
-            <a:off x="61475" y="4508750"/>
-            <a:ext cx="8678700" cy="323135"/>
-          </a:xfrm>
-          <a:prstGeom prst="rect">
-            <a:avLst/>
-          </a:prstGeom>
-          <a:noFill/>
-          <a:ln>
-            <a:noFill/>
-          </a:ln>
-        </p:spPr>
-        <p:txBody>
-          <a:bodyPr spcFirstLastPara="1" wrap="square" lIns="91425" tIns="91425" rIns="91425" bIns="91425" anchor="t" anchorCtr="0">
-            <a:spAutoFit/>
-          </a:bodyPr>
-          <a:lstStyle/>
-          <a:p>
-            <a:pPr marL="0" lvl="0" indent="0" rtl="0">
-              <a:spcBef>
-                <a:spcPts val="0"/>
-              </a:spcBef>
-              <a:spcAft>
-                <a:spcPts val="0"/>
-              </a:spcAft>
-              <a:buNone/>
-            </a:pPr>
-            <a:r>
-              <a:rPr lang="en" sz="900" dirty="0">
-                <a:latin typeface="Times New Roman"/>
-                <a:ea typeface="Times New Roman"/>
-                <a:cs typeface="Times New Roman"/>
-                <a:sym typeface="Times New Roman"/>
-              </a:rPr>
-              <a:t>                                                                                                        </a:t>
-            </a:r>
-            <a:r>
-              <a:rPr lang="en" sz="900" i="1" dirty="0">
-                <a:latin typeface="Times New Roman"/>
-                <a:ea typeface="Times New Roman"/>
-                <a:cs typeface="Times New Roman"/>
-                <a:sym typeface="Times New Roman"/>
-              </a:rPr>
-              <a:t>Department of AI-DS, K J Somaiya Institute of Technology, Sion, Mumbai </a:t>
-            </a:r>
-            <a:endParaRPr sz="900" i="1" dirty="0">
-              <a:latin typeface="Times New Roman"/>
-              <a:ea typeface="Times New Roman"/>
-              <a:cs typeface="Times New Roman"/>
-              <a:sym typeface="Times New Roman"/>
-            </a:endParaRPr>
-          </a:p>
-        </p:txBody>
-      </p:sp>
-      <p:sp>
-        <p:nvSpPr>
-          <p:cNvPr id="5" name="Google Shape;62;p13">
-            <a:extLst>
-              <a:ext uri="{FF2B5EF4-FFF2-40B4-BE49-F238E27FC236}">
-                <a16:creationId xmlns:a16="http://schemas.microsoft.com/office/drawing/2014/main" id="{91BF8489-284D-1A1F-9415-961D6333D42F}"/>
-              </a:ext>
-            </a:extLst>
-          </p:cNvPr>
-          <p:cNvSpPr txBox="1"/>
-          <p:nvPr/>
-        </p:nvSpPr>
-        <p:spPr>
-          <a:xfrm>
-            <a:off x="300000" y="1300000"/>
-            <a:ext cx="8500000" cy="400069"/>
-          </a:xfrm>
-          <a:prstGeom prst="rect">
-            <a:avLst/>
-          </a:prstGeom>
-          <a:noFill/>
-          <a:ln>
-            <a:noFill/>
-          </a:ln>
-        </p:spPr>
-        <p:txBody>
-          <a:bodyPr spcFirstLastPara="1" wrap="square" lIns="91425" tIns="45700" rIns="91425" bIns="45700" anchor="t" anchorCtr="0">
-            <a:spAutoFit/>
-          </a:bodyPr>
-          <a:lstStyle/>
-          <a:p>
-            <a:r>
-              <a:rPr lang="en-IN" sz="2000" b="1" dirty="0">
-                <a:solidFill>
-                  <a:srgbClr val="C00000"/>
-                </a:solidFill>
-                <a:latin typeface="Times New Roman"/>
-                <a:ea typeface="Times New Roman"/>
-                <a:cs typeface="Times New Roman"/>
-                <a:sym typeface="Times New Roman"/>
-              </a:rPr>
-              <a:t>References</a:t>
-            </a:r>
-            <a:endParaRPr lang="en-IN" sz="1800" dirty="0">
-              <a:latin typeface="Times New Roman"/>
-              <a:ea typeface="Times New Roman"/>
-              <a:cs typeface="Times New Roman"/>
-              <a:sym typeface="Times New Roman"/>
-            </a:endParaRPr>
-          </a:p>
-        </p:txBody>
-      </p:sp>
-      <p:sp>
-        <p:nvSpPr>
-          <p:cNvPr id="4" name="TextBox 3">
-            <a:extLst>
-              <a:ext uri="{FF2B5EF4-FFF2-40B4-BE49-F238E27FC236}">
-                <a16:creationId xmlns:a16="http://schemas.microsoft.com/office/drawing/2014/main" id="{B93DE465-11F0-F7E5-CB94-DFBD50D802D0}"/>
-              </a:ext>
-            </a:extLst>
-          </p:cNvPr>
-          <p:cNvSpPr txBox="1"/>
-          <p:nvPr/>
-        </p:nvSpPr>
-        <p:spPr>
-          <a:xfrm>
-            <a:off x="309741" y="1758791"/>
-            <a:ext cx="8515350" cy="2862322"/>
-          </a:xfrm>
-          <a:prstGeom prst="rect">
-            <a:avLst/>
-          </a:prstGeom>
-          <a:noFill/>
-        </p:spPr>
-        <p:txBody>
-          <a:bodyPr wrap="square">
-            <a:spAutoFit/>
-          </a:bodyPr>
-          <a:lstStyle/>
-          <a:p>
-            <a:pPr marL="342900" lvl="0" indent="-342900">
-              <a:buFont typeface="Arial" panose="020B0604020202020204" pitchFamily="34" charset="0"/>
-              <a:buChar char="•"/>
-            </a:pPr>
-            <a:r>
-              <a:rPr lang="en-IN" sz="1000" dirty="0">
-                <a:latin typeface="Times New Roman" panose="02020603050405020304" pitchFamily="18" charset="0"/>
-                <a:cs typeface="Times New Roman" panose="02020603050405020304" pitchFamily="18" charset="0"/>
-              </a:rPr>
-              <a:t>[1] A. K. Kazazi, Z. Li, M. N. </a:t>
-            </a:r>
-            <a:r>
-              <a:rPr lang="en-IN" sz="1000" dirty="0" err="1">
-                <a:latin typeface="Times New Roman" panose="02020603050405020304" pitchFamily="18" charset="0"/>
-                <a:cs typeface="Times New Roman" panose="02020603050405020304" pitchFamily="18" charset="0"/>
-              </a:rPr>
-              <a:t>Lessani</a:t>
-            </a:r>
-            <a:r>
-              <a:rPr lang="en-IN" sz="1000" dirty="0">
-                <a:latin typeface="Times New Roman" panose="02020603050405020304" pitchFamily="18" charset="0"/>
-                <a:cs typeface="Times New Roman" panose="02020603050405020304" pitchFamily="18" charset="0"/>
-              </a:rPr>
-              <a:t>, and G. Cervone, “From Questions to Queries: An AI-powered Multi-Agent Framework for Spatial Text-to-SQL,” </a:t>
-            </a:r>
-            <a:r>
-              <a:rPr lang="en-IN" sz="1000" dirty="0" err="1">
-                <a:latin typeface="Times New Roman" panose="02020603050405020304" pitchFamily="18" charset="0"/>
-                <a:cs typeface="Times New Roman" panose="02020603050405020304" pitchFamily="18" charset="0"/>
-              </a:rPr>
-              <a:t>arXiv</a:t>
-            </a:r>
-            <a:r>
-              <a:rPr lang="en-IN" sz="1000" dirty="0">
-                <a:latin typeface="Times New Roman" panose="02020603050405020304" pitchFamily="18" charset="0"/>
-                <a:cs typeface="Times New Roman" panose="02020603050405020304" pitchFamily="18" charset="0"/>
-              </a:rPr>
-              <a:t>, 2025.</a:t>
-            </a:r>
-          </a:p>
-          <a:p>
-            <a:pPr marL="342900" lvl="0" indent="-342900">
-              <a:buFont typeface="Arial" panose="020B0604020202020204" pitchFamily="34" charset="0"/>
-              <a:buChar char="•"/>
-            </a:pPr>
-            <a:endParaRPr lang="en-IN" sz="1000" dirty="0">
-              <a:latin typeface="Times New Roman" panose="02020603050405020304" pitchFamily="18" charset="0"/>
-              <a:cs typeface="Times New Roman" panose="02020603050405020304" pitchFamily="18" charset="0"/>
-            </a:endParaRPr>
-          </a:p>
-          <a:p>
-            <a:pPr marL="342900" lvl="0" indent="-342900">
-              <a:buFont typeface="Arial" panose="020B0604020202020204" pitchFamily="34" charset="0"/>
-              <a:buChar char="•"/>
-            </a:pPr>
-            <a:r>
-              <a:rPr lang="en-IN" sz="1000" dirty="0">
-                <a:latin typeface="Times New Roman" panose="02020603050405020304" pitchFamily="18" charset="0"/>
-                <a:cs typeface="Times New Roman" panose="02020603050405020304" pitchFamily="18" charset="0"/>
-              </a:rPr>
-              <a:t>[2] X. Zhang, F. Xiao, L. Yan, and Z. Zhang, “GS-SQL: </a:t>
-            </a:r>
-            <a:r>
-              <a:rPr lang="en-IN" sz="1000" dirty="0" err="1">
-                <a:latin typeface="Times New Roman" panose="02020603050405020304" pitchFamily="18" charset="0"/>
-                <a:cs typeface="Times New Roman" panose="02020603050405020304" pitchFamily="18" charset="0"/>
-              </a:rPr>
-              <a:t>Modeling</a:t>
-            </a:r>
-            <a:r>
-              <a:rPr lang="en-IN" sz="1000" dirty="0">
-                <a:latin typeface="Times New Roman" panose="02020603050405020304" pitchFamily="18" charset="0"/>
-                <a:cs typeface="Times New Roman" panose="02020603050405020304" pitchFamily="18" charset="0"/>
-              </a:rPr>
-              <a:t> Spatial Semantics in Spatial Text-to-SQL,” IJCNN, 2024.</a:t>
-            </a:r>
-          </a:p>
-          <a:p>
-            <a:pPr marL="342900" lvl="0" indent="-342900">
-              <a:buFont typeface="Arial" panose="020B0604020202020204" pitchFamily="34" charset="0"/>
-              <a:buChar char="•"/>
-            </a:pPr>
-            <a:endParaRPr lang="en-IN" sz="1000" dirty="0">
-              <a:latin typeface="Times New Roman" panose="02020603050405020304" pitchFamily="18" charset="0"/>
-              <a:cs typeface="Times New Roman" panose="02020603050405020304" pitchFamily="18" charset="0"/>
-            </a:endParaRPr>
-          </a:p>
-          <a:p>
-            <a:pPr marL="342900" lvl="0" indent="-342900">
-              <a:buFont typeface="Arial" panose="020B0604020202020204" pitchFamily="34" charset="0"/>
-              <a:buChar char="•"/>
-            </a:pPr>
-            <a:r>
-              <a:rPr lang="en-IN" sz="1000" dirty="0">
-                <a:latin typeface="Times New Roman" panose="02020603050405020304" pitchFamily="18" charset="0"/>
-                <a:cs typeface="Times New Roman" panose="02020603050405020304" pitchFamily="18" charset="0"/>
-              </a:rPr>
-              <a:t>[3] G. </a:t>
-            </a:r>
-            <a:r>
-              <a:rPr lang="en-IN" sz="1000" dirty="0" err="1">
-                <a:latin typeface="Times New Roman" panose="02020603050405020304" pitchFamily="18" charset="0"/>
-                <a:cs typeface="Times New Roman" panose="02020603050405020304" pitchFamily="18" charset="0"/>
-              </a:rPr>
-              <a:t>Andrienko</a:t>
-            </a:r>
-            <a:r>
-              <a:rPr lang="en-IN" sz="1000" dirty="0">
-                <a:latin typeface="Times New Roman" panose="02020603050405020304" pitchFamily="18" charset="0"/>
-                <a:cs typeface="Times New Roman" panose="02020603050405020304" pitchFamily="18" charset="0"/>
-              </a:rPr>
-              <a:t> et al., “</a:t>
-            </a:r>
-            <a:r>
-              <a:rPr lang="en-IN" sz="1000" dirty="0" err="1">
-                <a:latin typeface="Times New Roman" panose="02020603050405020304" pitchFamily="18" charset="0"/>
-                <a:cs typeface="Times New Roman" panose="02020603050405020304" pitchFamily="18" charset="0"/>
-              </a:rPr>
-              <a:t>Geovisual</a:t>
-            </a:r>
-            <a:r>
-              <a:rPr lang="en-IN" sz="1000" dirty="0">
-                <a:latin typeface="Times New Roman" panose="02020603050405020304" pitchFamily="18" charset="0"/>
-                <a:cs typeface="Times New Roman" panose="02020603050405020304" pitchFamily="18" charset="0"/>
-              </a:rPr>
-              <a:t> analytics for spatial decision support: Setting the research agenda,” Int. J. Geographical Information Science, vol. 21, pp. 839–857, 2007.</a:t>
-            </a:r>
-          </a:p>
-          <a:p>
-            <a:pPr marL="342900" lvl="0" indent="-342900">
-              <a:buFont typeface="Arial" panose="020B0604020202020204" pitchFamily="34" charset="0"/>
-              <a:buChar char="•"/>
-            </a:pPr>
-            <a:endParaRPr lang="en-IN" sz="1000" dirty="0">
-              <a:latin typeface="Times New Roman" panose="02020603050405020304" pitchFamily="18" charset="0"/>
-              <a:cs typeface="Times New Roman" panose="02020603050405020304" pitchFamily="18" charset="0"/>
-            </a:endParaRPr>
-          </a:p>
-          <a:p>
-            <a:pPr marL="342900" lvl="0" indent="-342900">
-              <a:buFont typeface="Arial" panose="020B0604020202020204" pitchFamily="34" charset="0"/>
-              <a:buChar char="•"/>
-            </a:pPr>
-            <a:r>
-              <a:rPr lang="en-IN" sz="1000" dirty="0">
-                <a:latin typeface="Times New Roman" panose="02020603050405020304" pitchFamily="18" charset="0"/>
-                <a:cs typeface="Times New Roman" panose="02020603050405020304" pitchFamily="18" charset="0"/>
-              </a:rPr>
-              <a:t>[4] R. Wen and S. Li, “Spatial Decision Support Systems with Automated Machine Learning: A Review,” ISPRS Int. J. Geo-Information, vol. 12, p. 12, 2022.</a:t>
-            </a:r>
-          </a:p>
-          <a:p>
-            <a:pPr marL="342900" lvl="0" indent="-342900">
-              <a:buFont typeface="Arial" panose="020B0604020202020204" pitchFamily="34" charset="0"/>
-              <a:buChar char="•"/>
-            </a:pPr>
-            <a:endParaRPr lang="en-IN" sz="1000" dirty="0">
-              <a:latin typeface="Times New Roman" panose="02020603050405020304" pitchFamily="18" charset="0"/>
-              <a:cs typeface="Times New Roman" panose="02020603050405020304" pitchFamily="18" charset="0"/>
-            </a:endParaRPr>
-          </a:p>
-          <a:p>
-            <a:pPr marL="342900" lvl="0" indent="-342900">
-              <a:buFont typeface="Arial" panose="020B0604020202020204" pitchFamily="34" charset="0"/>
-              <a:buChar char="•"/>
-            </a:pPr>
-            <a:r>
-              <a:rPr lang="en-IN" sz="1000" dirty="0">
-                <a:latin typeface="Times New Roman" panose="02020603050405020304" pitchFamily="18" charset="0"/>
-                <a:cs typeface="Times New Roman" panose="02020603050405020304" pitchFamily="18" charset="0"/>
-              </a:rPr>
-              <a:t>[5] G. </a:t>
-            </a:r>
-            <a:r>
-              <a:rPr lang="en-IN" sz="1000" dirty="0" err="1">
-                <a:latin typeface="Times New Roman" panose="02020603050405020304" pitchFamily="18" charset="0"/>
-                <a:cs typeface="Times New Roman" panose="02020603050405020304" pitchFamily="18" charset="0"/>
-              </a:rPr>
-              <a:t>Katsogiannis-Meimarakis</a:t>
-            </a:r>
-            <a:r>
-              <a:rPr lang="en-IN" sz="1000" dirty="0">
-                <a:latin typeface="Times New Roman" panose="02020603050405020304" pitchFamily="18" charset="0"/>
-                <a:cs typeface="Times New Roman" panose="02020603050405020304" pitchFamily="18" charset="0"/>
-              </a:rPr>
-              <a:t> and G. </a:t>
-            </a:r>
-            <a:r>
-              <a:rPr lang="en-IN" sz="1000" dirty="0" err="1">
-                <a:latin typeface="Times New Roman" panose="02020603050405020304" pitchFamily="18" charset="0"/>
-                <a:cs typeface="Times New Roman" panose="02020603050405020304" pitchFamily="18" charset="0"/>
-              </a:rPr>
-              <a:t>Koutrika</a:t>
-            </a:r>
-            <a:r>
-              <a:rPr lang="en-IN" sz="1000" dirty="0">
-                <a:latin typeface="Times New Roman" panose="02020603050405020304" pitchFamily="18" charset="0"/>
-                <a:cs typeface="Times New Roman" panose="02020603050405020304" pitchFamily="18" charset="0"/>
-              </a:rPr>
-              <a:t>, “A survey on deep learning approaches for Text-to-SQL,” The VLDB Journal, vol. 32, no. 4, pp. 905–936, 2023.</a:t>
-            </a:r>
-          </a:p>
-          <a:p>
-            <a:pPr marL="342900" lvl="0" indent="-342900">
-              <a:buFont typeface="Arial" panose="020B0604020202020204" pitchFamily="34" charset="0"/>
-              <a:buChar char="•"/>
-            </a:pPr>
-            <a:endParaRPr lang="en-IN" sz="1000" dirty="0">
-              <a:latin typeface="Times New Roman" panose="02020603050405020304" pitchFamily="18" charset="0"/>
-              <a:cs typeface="Times New Roman" panose="02020603050405020304" pitchFamily="18" charset="0"/>
-            </a:endParaRPr>
-          </a:p>
-          <a:p>
-            <a:pPr marL="342900" lvl="0" indent="-342900">
-              <a:buFont typeface="Arial" panose="020B0604020202020204" pitchFamily="34" charset="0"/>
-              <a:buChar char="•"/>
-            </a:pPr>
-            <a:r>
-              <a:rPr lang="en-IN" sz="1000" dirty="0">
-                <a:latin typeface="Times New Roman" panose="02020603050405020304" pitchFamily="18" charset="0"/>
-                <a:cs typeface="Times New Roman" panose="02020603050405020304" pitchFamily="18" charset="0"/>
-              </a:rPr>
-              <a:t>[6] M. </a:t>
-            </a:r>
-            <a:r>
-              <a:rPr lang="en-IN" sz="1000" dirty="0" err="1">
-                <a:latin typeface="Times New Roman" panose="02020603050405020304" pitchFamily="18" charset="0"/>
-                <a:cs typeface="Times New Roman" panose="02020603050405020304" pitchFamily="18" charset="0"/>
-              </a:rPr>
-              <a:t>Haklay</a:t>
-            </a:r>
-            <a:r>
-              <a:rPr lang="en-IN" sz="1000" dirty="0">
-                <a:latin typeface="Times New Roman" panose="02020603050405020304" pitchFamily="18" charset="0"/>
-                <a:cs typeface="Times New Roman" panose="02020603050405020304" pitchFamily="18" charset="0"/>
-              </a:rPr>
-              <a:t> and P. Weber, “OpenStreetMap: User-Generated Street Maps,” IEEE Pervasive Computing, vol. 7, no. 4, pp. 12–18, 2008.</a:t>
-            </a:r>
-          </a:p>
-          <a:p>
-            <a:pPr marL="342900" lvl="0" indent="-342900">
-              <a:buFont typeface="Arial" panose="020B0604020202020204" pitchFamily="34" charset="0"/>
-              <a:buChar char="•"/>
-            </a:pPr>
-            <a:endParaRPr lang="en-IN" sz="1000" dirty="0">
-              <a:latin typeface="Times New Roman" panose="02020603050405020304" pitchFamily="18" charset="0"/>
-              <a:cs typeface="Times New Roman" panose="02020603050405020304" pitchFamily="18" charset="0"/>
-            </a:endParaRPr>
-          </a:p>
-          <a:p>
-            <a:pPr marL="342900" lvl="0" indent="-342900">
-              <a:buFont typeface="Arial" panose="020B0604020202020204" pitchFamily="34" charset="0"/>
-              <a:buChar char="•"/>
-            </a:pPr>
-            <a:r>
-              <a:rPr lang="en-IN" sz="1000" dirty="0">
-                <a:latin typeface="Times New Roman" panose="02020603050405020304" pitchFamily="18" charset="0"/>
-                <a:cs typeface="Times New Roman" panose="02020603050405020304" pitchFamily="18" charset="0"/>
-              </a:rPr>
-              <a:t>[7] J. Malczewski, “GIS-based multicriteria decision analysis: a survey of the literature,” Int. J. Geographical Information Science, vol. 20, no. 7, pp. 703–726, 2006.</a:t>
-            </a:r>
-          </a:p>
-        </p:txBody>
-      </p:sp>
-    </p:spTree>
-    <p:extLst>
-      <p:ext uri="{BB962C8B-B14F-4D97-AF65-F5344CB8AC3E}">
-        <p14:creationId xmlns:p14="http://schemas.microsoft.com/office/powerpoint/2010/main" val="892815052"/>
       </p:ext>
     </p:extLst>
   </p:cSld>
@@ -14329,6 +14085,742 @@
         <p:cNvPr id="1" name="Shape 53">
           <a:extLst>
             <a:ext uri="{FF2B5EF4-FFF2-40B4-BE49-F238E27FC236}">
+              <a16:creationId xmlns:a16="http://schemas.microsoft.com/office/drawing/2014/main" id="{2DDF6233-2213-9DE7-0384-FD2E5E619399}"/>
+            </a:ext>
+          </a:extLst>
+        </p:cNvPr>
+        <p:cNvGrpSpPr/>
+        <p:nvPr/>
+      </p:nvGrpSpPr>
+      <p:grpSpPr>
+        <a:xfrm>
+          <a:off x="0" y="0"/>
+          <a:ext cx="0" cy="0"/>
+          <a:chOff x="0" y="0"/>
+          <a:chExt cx="0" cy="0"/>
+        </a:xfrm>
+      </p:grpSpPr>
+      <p:sp>
+        <p:nvSpPr>
+          <p:cNvPr id="2" name="TextBox 1">
+            <a:extLst>
+              <a:ext uri="{FF2B5EF4-FFF2-40B4-BE49-F238E27FC236}">
+                <a16:creationId xmlns:a16="http://schemas.microsoft.com/office/drawing/2014/main" id="{B5EF41DB-BA66-B530-3083-2D5827F8E522}"/>
+              </a:ext>
+            </a:extLst>
+          </p:cNvPr>
+          <p:cNvSpPr txBox="1"/>
+          <p:nvPr/>
+        </p:nvSpPr>
+        <p:spPr>
+          <a:xfrm>
+            <a:off x="257175" y="4836100"/>
+            <a:ext cx="1343025" cy="276999"/>
+          </a:xfrm>
+          <a:prstGeom prst="rect">
+            <a:avLst/>
+          </a:prstGeom>
+          <a:noFill/>
+        </p:spPr>
+        <p:txBody>
+          <a:bodyPr wrap="square" rtlCol="0">
+            <a:spAutoFit/>
+          </a:bodyPr>
+          <a:lstStyle/>
+          <a:p>
+            <a:r>
+              <a:rPr lang="en-US" sz="1200" dirty="0">
+                <a:solidFill>
+                  <a:schemeClr val="bg1"/>
+                </a:solidFill>
+                <a:latin typeface="Times New Roman" panose="02020603050405020304" pitchFamily="18" charset="0"/>
+                <a:cs typeface="Times New Roman" panose="02020603050405020304" pitchFamily="18" charset="0"/>
+              </a:rPr>
+              <a:t>26/6/2023</a:t>
+            </a:r>
+          </a:p>
+        </p:txBody>
+      </p:sp>
+      <p:sp>
+        <p:nvSpPr>
+          <p:cNvPr id="15" name="Google Shape;97;p1">
+            <a:extLst>
+              <a:ext uri="{FF2B5EF4-FFF2-40B4-BE49-F238E27FC236}">
+                <a16:creationId xmlns:a16="http://schemas.microsoft.com/office/drawing/2014/main" id="{B0F60ECF-C2DE-ECD9-BE9F-4561339DA83B}"/>
+              </a:ext>
+            </a:extLst>
+          </p:cNvPr>
+          <p:cNvSpPr/>
+          <p:nvPr/>
+        </p:nvSpPr>
+        <p:spPr>
+          <a:xfrm>
+            <a:off x="8910006" y="1217600"/>
+            <a:ext cx="230488" cy="3941298"/>
+          </a:xfrm>
+          <a:prstGeom prst="rect">
+            <a:avLst/>
+          </a:prstGeom>
+          <a:solidFill>
+            <a:srgbClr val="C00000"/>
+          </a:solidFill>
+          <a:ln>
+            <a:noFill/>
+          </a:ln>
+        </p:spPr>
+        <p:txBody>
+          <a:bodyPr spcFirstLastPara="1" wrap="square" lIns="91425" tIns="45700" rIns="91425" bIns="45700" anchor="ctr" anchorCtr="0">
+            <a:noAutofit/>
+          </a:bodyPr>
+          <a:lstStyle/>
+          <a:p>
+            <a:pPr marL="0" marR="0" lvl="0" indent="0" algn="ctr" rtl="0">
+              <a:lnSpc>
+                <a:spcPct val="100000"/>
+              </a:lnSpc>
+              <a:spcBef>
+                <a:spcPts val="0"/>
+              </a:spcBef>
+              <a:spcAft>
+                <a:spcPts val="0"/>
+              </a:spcAft>
+              <a:buClr>
+                <a:srgbClr val="000000"/>
+              </a:buClr>
+              <a:buSzPts val="2493"/>
+              <a:buFont typeface="Arial"/>
+              <a:buNone/>
+            </a:pPr>
+            <a:endParaRPr sz="2493" b="0" i="0" u="none" strike="noStrike" cap="none">
+              <a:solidFill>
+                <a:schemeClr val="lt1"/>
+              </a:solidFill>
+              <a:latin typeface="Arial"/>
+              <a:ea typeface="Arial"/>
+              <a:cs typeface="Arial"/>
+              <a:sym typeface="Arial"/>
+            </a:endParaRPr>
+          </a:p>
+        </p:txBody>
+      </p:sp>
+      <p:sp>
+        <p:nvSpPr>
+          <p:cNvPr id="16" name="Google Shape;97;p1">
+            <a:extLst>
+              <a:ext uri="{FF2B5EF4-FFF2-40B4-BE49-F238E27FC236}">
+                <a16:creationId xmlns:a16="http://schemas.microsoft.com/office/drawing/2014/main" id="{9E889681-3007-B447-1F1F-CB57E44079C2}"/>
+              </a:ext>
+            </a:extLst>
+          </p:cNvPr>
+          <p:cNvSpPr/>
+          <p:nvPr/>
+        </p:nvSpPr>
+        <p:spPr>
+          <a:xfrm>
+            <a:off x="2105025" y="4836100"/>
+            <a:ext cx="6807206" cy="322797"/>
+          </a:xfrm>
+          <a:prstGeom prst="rect">
+            <a:avLst/>
+          </a:prstGeom>
+          <a:solidFill>
+            <a:srgbClr val="C00000"/>
+          </a:solidFill>
+          <a:ln>
+            <a:noFill/>
+          </a:ln>
+        </p:spPr>
+        <p:txBody>
+          <a:bodyPr spcFirstLastPara="1" wrap="square" lIns="91425" tIns="45700" rIns="91425" bIns="45700" anchor="ctr" anchorCtr="0">
+            <a:noAutofit/>
+          </a:bodyPr>
+          <a:lstStyle/>
+          <a:p>
+            <a:pPr marL="0" marR="0" lvl="0" indent="0" algn="ctr" rtl="0">
+              <a:lnSpc>
+                <a:spcPct val="100000"/>
+              </a:lnSpc>
+              <a:spcBef>
+                <a:spcPts val="0"/>
+              </a:spcBef>
+              <a:spcAft>
+                <a:spcPts val="0"/>
+              </a:spcAft>
+              <a:buClr>
+                <a:srgbClr val="000000"/>
+              </a:buClr>
+              <a:buSzPts val="2493"/>
+              <a:buFont typeface="Arial"/>
+              <a:buNone/>
+            </a:pPr>
+            <a:endParaRPr sz="2493" b="0" i="0" u="none" strike="noStrike" cap="none">
+              <a:solidFill>
+                <a:schemeClr val="lt1"/>
+              </a:solidFill>
+              <a:latin typeface="Arial"/>
+              <a:ea typeface="Arial"/>
+              <a:cs typeface="Arial"/>
+              <a:sym typeface="Arial"/>
+            </a:endParaRPr>
+          </a:p>
+        </p:txBody>
+      </p:sp>
+      <p:sp>
+        <p:nvSpPr>
+          <p:cNvPr id="17" name="Rectangle 16">
+            <a:extLst>
+              <a:ext uri="{FF2B5EF4-FFF2-40B4-BE49-F238E27FC236}">
+                <a16:creationId xmlns:a16="http://schemas.microsoft.com/office/drawing/2014/main" id="{685EDB76-054D-6747-B086-4FC3E0155731}"/>
+              </a:ext>
+            </a:extLst>
+          </p:cNvPr>
+          <p:cNvSpPr/>
+          <p:nvPr/>
+        </p:nvSpPr>
+        <p:spPr>
+          <a:xfrm>
+            <a:off x="0" y="4836100"/>
+            <a:ext cx="2105025" cy="322798"/>
+          </a:xfrm>
+          <a:prstGeom prst="rect">
+            <a:avLst/>
+          </a:prstGeom>
+          <a:solidFill>
+            <a:srgbClr val="FF0000"/>
+          </a:solidFill>
+          <a:ln>
+            <a:noFill/>
+          </a:ln>
+        </p:spPr>
+        <p:style>
+          <a:lnRef idx="2">
+            <a:schemeClr val="accent1">
+              <a:shade val="50000"/>
+            </a:schemeClr>
+          </a:lnRef>
+          <a:fillRef idx="1">
+            <a:schemeClr val="accent1"/>
+          </a:fillRef>
+          <a:effectRef idx="0">
+            <a:schemeClr val="accent1"/>
+          </a:effectRef>
+          <a:fontRef idx="minor">
+            <a:schemeClr val="lt1"/>
+          </a:fontRef>
+        </p:style>
+        <p:txBody>
+          <a:bodyPr rtlCol="0" anchor="ctr"/>
+          <a:lstStyle/>
+          <a:p>
+            <a:endParaRPr lang="en-US" sz="1200" dirty="0">
+              <a:latin typeface="Times New Roman" pitchFamily="18" charset="0"/>
+              <a:cs typeface="Times New Roman" pitchFamily="18" charset="0"/>
+            </a:endParaRPr>
+          </a:p>
+        </p:txBody>
+      </p:sp>
+      <p:pic>
+        <p:nvPicPr>
+          <p:cNvPr id="8" name="Picture 2">
+            <a:extLst>
+              <a:ext uri="{FF2B5EF4-FFF2-40B4-BE49-F238E27FC236}">
+                <a16:creationId xmlns:a16="http://schemas.microsoft.com/office/drawing/2014/main" id="{7264FC4E-3387-E874-ECFE-049C3FA8DB33}"/>
+              </a:ext>
+            </a:extLst>
+          </p:cNvPr>
+          <p:cNvPicPr>
+            <a:picLocks noChangeAspect="1" noChangeArrowheads="1"/>
+          </p:cNvPicPr>
+          <p:nvPr/>
+        </p:nvPicPr>
+        <p:blipFill>
+          <a:blip r:embed="rId3">
+            <a:extLst>
+              <a:ext uri="{28A0092B-C50C-407E-A947-70E740481C1C}">
+                <a14:useLocalDpi xmlns:a14="http://schemas.microsoft.com/office/drawing/2010/main" val="0"/>
+              </a:ext>
+            </a:extLst>
+          </a:blip>
+          <a:srcRect/>
+          <a:stretch>
+            <a:fillRect/>
+          </a:stretch>
+        </p:blipFill>
+        <p:spPr bwMode="auto">
+          <a:xfrm>
+            <a:off x="0" y="0"/>
+            <a:ext cx="9140493" cy="1332186"/>
+          </a:xfrm>
+          <a:prstGeom prst="rect">
+            <a:avLst/>
+          </a:prstGeom>
+          <a:noFill/>
+          <a:ln>
+            <a:noFill/>
+          </a:ln>
+          <a:effectLst/>
+          <a:extLst>
+            <a:ext uri="{909E8E84-426E-40DD-AFC4-6F175D3DCCD1}">
+              <a14:hiddenFill xmlns:a14="http://schemas.microsoft.com/office/drawing/2010/main">
+                <a:solidFill>
+                  <a:schemeClr val="accent1"/>
+                </a:solidFill>
+              </a14:hiddenFill>
+            </a:ext>
+            <a:ext uri="{91240B29-F687-4F45-9708-019B960494DF}">
+              <a14:hiddenLine xmlns:a14="http://schemas.microsoft.com/office/drawing/2010/main" w="9525">
+                <a:solidFill>
+                  <a:schemeClr val="tx1"/>
+                </a:solidFill>
+                <a:miter lim="800000"/>
+                <a:headEnd/>
+                <a:tailEnd/>
+              </a14:hiddenLine>
+            </a:ext>
+            <a:ext uri="{AF507438-7753-43E0-B8FC-AC1667EBCBE1}">
+              <a14:hiddenEffects xmlns:a14="http://schemas.microsoft.com/office/drawing/2010/main">
+                <a:effectLst>
+                  <a:outerShdw dist="35921" dir="2700000" algn="ctr" rotWithShape="0">
+                    <a:schemeClr val="bg2"/>
+                  </a:outerShdw>
+                </a:effectLst>
+              </a14:hiddenEffects>
+            </a:ext>
+          </a:extLst>
+        </p:spPr>
+      </p:pic>
+      <p:sp>
+        <p:nvSpPr>
+          <p:cNvPr id="7" name="Google Shape;59;p13">
+            <a:extLst>
+              <a:ext uri="{FF2B5EF4-FFF2-40B4-BE49-F238E27FC236}">
+                <a16:creationId xmlns:a16="http://schemas.microsoft.com/office/drawing/2014/main" id="{B99E41EF-F00B-22A5-7155-796E4FC78B49}"/>
+              </a:ext>
+            </a:extLst>
+          </p:cNvPr>
+          <p:cNvSpPr txBox="1"/>
+          <p:nvPr/>
+        </p:nvSpPr>
+        <p:spPr>
+          <a:xfrm>
+            <a:off x="61475" y="4508750"/>
+            <a:ext cx="8678700" cy="323135"/>
+          </a:xfrm>
+          <a:prstGeom prst="rect">
+            <a:avLst/>
+          </a:prstGeom>
+          <a:noFill/>
+          <a:ln>
+            <a:noFill/>
+          </a:ln>
+        </p:spPr>
+        <p:txBody>
+          <a:bodyPr spcFirstLastPara="1" wrap="square" lIns="91425" tIns="91425" rIns="91425" bIns="91425" anchor="t" anchorCtr="0">
+            <a:spAutoFit/>
+          </a:bodyPr>
+          <a:lstStyle/>
+          <a:p>
+            <a:pPr marL="0" lvl="0" indent="0" rtl="0">
+              <a:spcBef>
+                <a:spcPts val="0"/>
+              </a:spcBef>
+              <a:spcAft>
+                <a:spcPts val="0"/>
+              </a:spcAft>
+              <a:buNone/>
+            </a:pPr>
+            <a:r>
+              <a:rPr lang="en" sz="900" dirty="0">
+                <a:latin typeface="Times New Roman"/>
+                <a:ea typeface="Times New Roman"/>
+                <a:cs typeface="Times New Roman"/>
+                <a:sym typeface="Times New Roman"/>
+              </a:rPr>
+              <a:t>                                                                                                        </a:t>
+            </a:r>
+            <a:r>
+              <a:rPr lang="en" sz="900" i="1" dirty="0">
+                <a:latin typeface="Times New Roman"/>
+                <a:ea typeface="Times New Roman"/>
+                <a:cs typeface="Times New Roman"/>
+                <a:sym typeface="Times New Roman"/>
+              </a:rPr>
+              <a:t>Department of AI-DS, K J Somaiya Institute of Technology, Sion, Mumbai </a:t>
+            </a:r>
+            <a:endParaRPr sz="900" i="1" dirty="0">
+              <a:latin typeface="Times New Roman"/>
+              <a:ea typeface="Times New Roman"/>
+              <a:cs typeface="Times New Roman"/>
+              <a:sym typeface="Times New Roman"/>
+            </a:endParaRPr>
+          </a:p>
+        </p:txBody>
+      </p:sp>
+      <p:sp>
+        <p:nvSpPr>
+          <p:cNvPr id="5" name="Google Shape;62;p13">
+            <a:extLst>
+              <a:ext uri="{FF2B5EF4-FFF2-40B4-BE49-F238E27FC236}">
+                <a16:creationId xmlns:a16="http://schemas.microsoft.com/office/drawing/2014/main" id="{91BF8489-284D-1A1F-9415-961D6333D42F}"/>
+              </a:ext>
+            </a:extLst>
+          </p:cNvPr>
+          <p:cNvSpPr txBox="1"/>
+          <p:nvPr/>
+        </p:nvSpPr>
+        <p:spPr>
+          <a:xfrm>
+            <a:off x="300000" y="1300000"/>
+            <a:ext cx="8500000" cy="400069"/>
+          </a:xfrm>
+          <a:prstGeom prst="rect">
+            <a:avLst/>
+          </a:prstGeom>
+          <a:noFill/>
+          <a:ln>
+            <a:noFill/>
+          </a:ln>
+        </p:spPr>
+        <p:txBody>
+          <a:bodyPr spcFirstLastPara="1" wrap="square" lIns="91425" tIns="45700" rIns="91425" bIns="45700" anchor="t" anchorCtr="0">
+            <a:spAutoFit/>
+          </a:bodyPr>
+          <a:lstStyle/>
+          <a:p>
+            <a:r>
+              <a:rPr lang="en-IN" sz="2000" b="1" dirty="0">
+                <a:solidFill>
+                  <a:srgbClr val="C00000"/>
+                </a:solidFill>
+                <a:latin typeface="Times New Roman"/>
+                <a:ea typeface="Times New Roman"/>
+                <a:cs typeface="Times New Roman"/>
+                <a:sym typeface="Times New Roman"/>
+              </a:rPr>
+              <a:t>References</a:t>
+            </a:r>
+            <a:endParaRPr lang="en-IN" sz="1800" dirty="0">
+              <a:latin typeface="Times New Roman"/>
+              <a:ea typeface="Times New Roman"/>
+              <a:cs typeface="Times New Roman"/>
+              <a:sym typeface="Times New Roman"/>
+            </a:endParaRPr>
+          </a:p>
+        </p:txBody>
+      </p:sp>
+      <p:sp>
+        <p:nvSpPr>
+          <p:cNvPr id="4" name="TextBox 3">
+            <a:extLst>
+              <a:ext uri="{FF2B5EF4-FFF2-40B4-BE49-F238E27FC236}">
+                <a16:creationId xmlns:a16="http://schemas.microsoft.com/office/drawing/2014/main" id="{B93DE465-11F0-F7E5-CB94-DFBD50D802D0}"/>
+              </a:ext>
+            </a:extLst>
+          </p:cNvPr>
+          <p:cNvSpPr txBox="1"/>
+          <p:nvPr/>
+        </p:nvSpPr>
+        <p:spPr>
+          <a:xfrm>
+            <a:off x="309741" y="1758791"/>
+            <a:ext cx="8515350" cy="2862322"/>
+          </a:xfrm>
+          <a:prstGeom prst="rect">
+            <a:avLst/>
+          </a:prstGeom>
+          <a:noFill/>
+        </p:spPr>
+        <p:txBody>
+          <a:bodyPr wrap="square">
+            <a:spAutoFit/>
+          </a:bodyPr>
+          <a:lstStyle/>
+          <a:p>
+            <a:pPr marL="342900" lvl="0" indent="-342900">
+              <a:buFont typeface="Arial" panose="020B0604020202020204" pitchFamily="34" charset="0"/>
+              <a:buChar char="•"/>
+            </a:pPr>
+            <a:r>
+              <a:rPr lang="en-IN" sz="1000" dirty="0">
+                <a:latin typeface="Times New Roman" panose="02020603050405020304" pitchFamily="18" charset="0"/>
+                <a:cs typeface="Times New Roman" panose="02020603050405020304" pitchFamily="18" charset="0"/>
+              </a:rPr>
+              <a:t>[1] A. K. Kazazi, Z. Li, M. N. </a:t>
+            </a:r>
+            <a:r>
+              <a:rPr lang="en-IN" sz="1000" dirty="0" err="1">
+                <a:latin typeface="Times New Roman" panose="02020603050405020304" pitchFamily="18" charset="0"/>
+                <a:cs typeface="Times New Roman" panose="02020603050405020304" pitchFamily="18" charset="0"/>
+              </a:rPr>
+              <a:t>Lessani</a:t>
+            </a:r>
+            <a:r>
+              <a:rPr lang="en-IN" sz="1000" dirty="0">
+                <a:latin typeface="Times New Roman" panose="02020603050405020304" pitchFamily="18" charset="0"/>
+                <a:cs typeface="Times New Roman" panose="02020603050405020304" pitchFamily="18" charset="0"/>
+              </a:rPr>
+              <a:t>, and G. Cervone, “From Questions to Queries: An AI-powered Multi-Agent Framework for Spatial Text-to-SQL,” </a:t>
+            </a:r>
+            <a:r>
+              <a:rPr lang="en-IN" sz="1000" dirty="0" err="1">
+                <a:latin typeface="Times New Roman" panose="02020603050405020304" pitchFamily="18" charset="0"/>
+                <a:cs typeface="Times New Roman" panose="02020603050405020304" pitchFamily="18" charset="0"/>
+              </a:rPr>
+              <a:t>arXiv</a:t>
+            </a:r>
+            <a:r>
+              <a:rPr lang="en-IN" sz="1000" dirty="0">
+                <a:latin typeface="Times New Roman" panose="02020603050405020304" pitchFamily="18" charset="0"/>
+                <a:cs typeface="Times New Roman" panose="02020603050405020304" pitchFamily="18" charset="0"/>
+              </a:rPr>
+              <a:t>, 2025.</a:t>
+            </a:r>
+          </a:p>
+          <a:p>
+            <a:pPr marL="342900" lvl="0" indent="-342900">
+              <a:buFont typeface="Arial" panose="020B0604020202020204" pitchFamily="34" charset="0"/>
+              <a:buChar char="•"/>
+            </a:pPr>
+            <a:endParaRPr lang="en-IN" sz="1000" dirty="0">
+              <a:latin typeface="Times New Roman" panose="02020603050405020304" pitchFamily="18" charset="0"/>
+              <a:cs typeface="Times New Roman" panose="02020603050405020304" pitchFamily="18" charset="0"/>
+            </a:endParaRPr>
+          </a:p>
+          <a:p>
+            <a:pPr marL="342900" lvl="0" indent="-342900">
+              <a:buFont typeface="Arial" panose="020B0604020202020204" pitchFamily="34" charset="0"/>
+              <a:buChar char="•"/>
+            </a:pPr>
+            <a:r>
+              <a:rPr lang="en-IN" sz="1000" dirty="0">
+                <a:latin typeface="Times New Roman" panose="02020603050405020304" pitchFamily="18" charset="0"/>
+                <a:cs typeface="Times New Roman" panose="02020603050405020304" pitchFamily="18" charset="0"/>
+              </a:rPr>
+              <a:t>[2] X. Zhang, F. Xiao, L. Yan, and Z. Zhang, “GS-SQL: </a:t>
+            </a:r>
+            <a:r>
+              <a:rPr lang="en-IN" sz="1000" dirty="0" err="1">
+                <a:latin typeface="Times New Roman" panose="02020603050405020304" pitchFamily="18" charset="0"/>
+                <a:cs typeface="Times New Roman" panose="02020603050405020304" pitchFamily="18" charset="0"/>
+              </a:rPr>
+              <a:t>Modeling</a:t>
+            </a:r>
+            <a:r>
+              <a:rPr lang="en-IN" sz="1000" dirty="0">
+                <a:latin typeface="Times New Roman" panose="02020603050405020304" pitchFamily="18" charset="0"/>
+                <a:cs typeface="Times New Roman" panose="02020603050405020304" pitchFamily="18" charset="0"/>
+              </a:rPr>
+              <a:t> Spatial Semantics in Spatial Text-to-SQL,” IJCNN, 2024.</a:t>
+            </a:r>
+          </a:p>
+          <a:p>
+            <a:pPr marL="342900" lvl="0" indent="-342900">
+              <a:buFont typeface="Arial" panose="020B0604020202020204" pitchFamily="34" charset="0"/>
+              <a:buChar char="•"/>
+            </a:pPr>
+            <a:endParaRPr lang="en-IN" sz="1000" dirty="0">
+              <a:latin typeface="Times New Roman" panose="02020603050405020304" pitchFamily="18" charset="0"/>
+              <a:cs typeface="Times New Roman" panose="02020603050405020304" pitchFamily="18" charset="0"/>
+            </a:endParaRPr>
+          </a:p>
+          <a:p>
+            <a:pPr marL="342900" lvl="0" indent="-342900">
+              <a:buFont typeface="Arial" panose="020B0604020202020204" pitchFamily="34" charset="0"/>
+              <a:buChar char="•"/>
+            </a:pPr>
+            <a:r>
+              <a:rPr lang="en-IN" sz="1000" dirty="0">
+                <a:latin typeface="Times New Roman" panose="02020603050405020304" pitchFamily="18" charset="0"/>
+                <a:cs typeface="Times New Roman" panose="02020603050405020304" pitchFamily="18" charset="0"/>
+              </a:rPr>
+              <a:t>[3] G. </a:t>
+            </a:r>
+            <a:r>
+              <a:rPr lang="en-IN" sz="1000" dirty="0" err="1">
+                <a:latin typeface="Times New Roman" panose="02020603050405020304" pitchFamily="18" charset="0"/>
+                <a:cs typeface="Times New Roman" panose="02020603050405020304" pitchFamily="18" charset="0"/>
+              </a:rPr>
+              <a:t>Andrienko</a:t>
+            </a:r>
+            <a:r>
+              <a:rPr lang="en-IN" sz="1000" dirty="0">
+                <a:latin typeface="Times New Roman" panose="02020603050405020304" pitchFamily="18" charset="0"/>
+                <a:cs typeface="Times New Roman" panose="02020603050405020304" pitchFamily="18" charset="0"/>
+              </a:rPr>
+              <a:t> et al., “</a:t>
+            </a:r>
+            <a:r>
+              <a:rPr lang="en-IN" sz="1000" dirty="0" err="1">
+                <a:latin typeface="Times New Roman" panose="02020603050405020304" pitchFamily="18" charset="0"/>
+                <a:cs typeface="Times New Roman" panose="02020603050405020304" pitchFamily="18" charset="0"/>
+              </a:rPr>
+              <a:t>Geovisual</a:t>
+            </a:r>
+            <a:r>
+              <a:rPr lang="en-IN" sz="1000" dirty="0">
+                <a:latin typeface="Times New Roman" panose="02020603050405020304" pitchFamily="18" charset="0"/>
+                <a:cs typeface="Times New Roman" panose="02020603050405020304" pitchFamily="18" charset="0"/>
+              </a:rPr>
+              <a:t> analytics for spatial decision support: Setting the research agenda,” Int. J. Geographical Information Science, vol. 21, pp. 839–857, 2007.</a:t>
+            </a:r>
+          </a:p>
+          <a:p>
+            <a:pPr marL="342900" lvl="0" indent="-342900">
+              <a:buFont typeface="Arial" panose="020B0604020202020204" pitchFamily="34" charset="0"/>
+              <a:buChar char="•"/>
+            </a:pPr>
+            <a:endParaRPr lang="en-IN" sz="1000" dirty="0">
+              <a:latin typeface="Times New Roman" panose="02020603050405020304" pitchFamily="18" charset="0"/>
+              <a:cs typeface="Times New Roman" panose="02020603050405020304" pitchFamily="18" charset="0"/>
+            </a:endParaRPr>
+          </a:p>
+          <a:p>
+            <a:pPr marL="342900" lvl="0" indent="-342900">
+              <a:buFont typeface="Arial" panose="020B0604020202020204" pitchFamily="34" charset="0"/>
+              <a:buChar char="•"/>
+            </a:pPr>
+            <a:r>
+              <a:rPr lang="en-IN" sz="1000" dirty="0">
+                <a:latin typeface="Times New Roman" panose="02020603050405020304" pitchFamily="18" charset="0"/>
+                <a:cs typeface="Times New Roman" panose="02020603050405020304" pitchFamily="18" charset="0"/>
+              </a:rPr>
+              <a:t>[4] R. Wen and S. Li, “Spatial Decision Support Systems with Automated Machine Learning: A Review,” ISPRS Int. J. Geo-Information, vol. 12, p. 12, 2022.</a:t>
+            </a:r>
+          </a:p>
+          <a:p>
+            <a:pPr marL="342900" lvl="0" indent="-342900">
+              <a:buFont typeface="Arial" panose="020B0604020202020204" pitchFamily="34" charset="0"/>
+              <a:buChar char="•"/>
+            </a:pPr>
+            <a:endParaRPr lang="en-IN" sz="1000" dirty="0">
+              <a:latin typeface="Times New Roman" panose="02020603050405020304" pitchFamily="18" charset="0"/>
+              <a:cs typeface="Times New Roman" panose="02020603050405020304" pitchFamily="18" charset="0"/>
+            </a:endParaRPr>
+          </a:p>
+          <a:p>
+            <a:pPr marL="342900" lvl="0" indent="-342900">
+              <a:buFont typeface="Arial" panose="020B0604020202020204" pitchFamily="34" charset="0"/>
+              <a:buChar char="•"/>
+            </a:pPr>
+            <a:r>
+              <a:rPr lang="en-IN" sz="1000" dirty="0">
+                <a:latin typeface="Times New Roman" panose="02020603050405020304" pitchFamily="18" charset="0"/>
+                <a:cs typeface="Times New Roman" panose="02020603050405020304" pitchFamily="18" charset="0"/>
+              </a:rPr>
+              <a:t>[5] G. </a:t>
+            </a:r>
+            <a:r>
+              <a:rPr lang="en-IN" sz="1000" dirty="0" err="1">
+                <a:latin typeface="Times New Roman" panose="02020603050405020304" pitchFamily="18" charset="0"/>
+                <a:cs typeface="Times New Roman" panose="02020603050405020304" pitchFamily="18" charset="0"/>
+              </a:rPr>
+              <a:t>Katsogiannis-Meimarakis</a:t>
+            </a:r>
+            <a:r>
+              <a:rPr lang="en-IN" sz="1000" dirty="0">
+                <a:latin typeface="Times New Roman" panose="02020603050405020304" pitchFamily="18" charset="0"/>
+                <a:cs typeface="Times New Roman" panose="02020603050405020304" pitchFamily="18" charset="0"/>
+              </a:rPr>
+              <a:t> and G. </a:t>
+            </a:r>
+            <a:r>
+              <a:rPr lang="en-IN" sz="1000" dirty="0" err="1">
+                <a:latin typeface="Times New Roman" panose="02020603050405020304" pitchFamily="18" charset="0"/>
+                <a:cs typeface="Times New Roman" panose="02020603050405020304" pitchFamily="18" charset="0"/>
+              </a:rPr>
+              <a:t>Koutrika</a:t>
+            </a:r>
+            <a:r>
+              <a:rPr lang="en-IN" sz="1000" dirty="0">
+                <a:latin typeface="Times New Roman" panose="02020603050405020304" pitchFamily="18" charset="0"/>
+                <a:cs typeface="Times New Roman" panose="02020603050405020304" pitchFamily="18" charset="0"/>
+              </a:rPr>
+              <a:t>, “A survey on deep learning approaches for Text-to-SQL,” The VLDB Journal, vol. 32, no. 4, pp. 905–936, 2023.</a:t>
+            </a:r>
+          </a:p>
+          <a:p>
+            <a:pPr marL="342900" lvl="0" indent="-342900">
+              <a:buFont typeface="Arial" panose="020B0604020202020204" pitchFamily="34" charset="0"/>
+              <a:buChar char="•"/>
+            </a:pPr>
+            <a:endParaRPr lang="en-IN" sz="1000" dirty="0">
+              <a:latin typeface="Times New Roman" panose="02020603050405020304" pitchFamily="18" charset="0"/>
+              <a:cs typeface="Times New Roman" panose="02020603050405020304" pitchFamily="18" charset="0"/>
+            </a:endParaRPr>
+          </a:p>
+          <a:p>
+            <a:pPr marL="342900" lvl="0" indent="-342900">
+              <a:buFont typeface="Arial" panose="020B0604020202020204" pitchFamily="34" charset="0"/>
+              <a:buChar char="•"/>
+            </a:pPr>
+            <a:r>
+              <a:rPr lang="en-IN" sz="1000" dirty="0">
+                <a:latin typeface="Times New Roman" panose="02020603050405020304" pitchFamily="18" charset="0"/>
+                <a:cs typeface="Times New Roman" panose="02020603050405020304" pitchFamily="18" charset="0"/>
+              </a:rPr>
+              <a:t>[6] M. </a:t>
+            </a:r>
+            <a:r>
+              <a:rPr lang="en-IN" sz="1000" dirty="0" err="1">
+                <a:latin typeface="Times New Roman" panose="02020603050405020304" pitchFamily="18" charset="0"/>
+                <a:cs typeface="Times New Roman" panose="02020603050405020304" pitchFamily="18" charset="0"/>
+              </a:rPr>
+              <a:t>Haklay</a:t>
+            </a:r>
+            <a:r>
+              <a:rPr lang="en-IN" sz="1000" dirty="0">
+                <a:latin typeface="Times New Roman" panose="02020603050405020304" pitchFamily="18" charset="0"/>
+                <a:cs typeface="Times New Roman" panose="02020603050405020304" pitchFamily="18" charset="0"/>
+              </a:rPr>
+              <a:t> and P. Weber, “OpenStreetMap: User-Generated Street Maps,” IEEE Pervasive Computing, vol. 7, no. 4, pp. 12–18, 2008.</a:t>
+            </a:r>
+          </a:p>
+          <a:p>
+            <a:pPr marL="342900" lvl="0" indent="-342900">
+              <a:buFont typeface="Arial" panose="020B0604020202020204" pitchFamily="34" charset="0"/>
+              <a:buChar char="•"/>
+            </a:pPr>
+            <a:endParaRPr lang="en-IN" sz="1000" dirty="0">
+              <a:latin typeface="Times New Roman" panose="02020603050405020304" pitchFamily="18" charset="0"/>
+              <a:cs typeface="Times New Roman" panose="02020603050405020304" pitchFamily="18" charset="0"/>
+            </a:endParaRPr>
+          </a:p>
+          <a:p>
+            <a:pPr marL="342900" lvl="0" indent="-342900">
+              <a:buFont typeface="Arial" panose="020B0604020202020204" pitchFamily="34" charset="0"/>
+              <a:buChar char="•"/>
+            </a:pPr>
+            <a:r>
+              <a:rPr lang="en-IN" sz="1000" dirty="0">
+                <a:latin typeface="Times New Roman" panose="02020603050405020304" pitchFamily="18" charset="0"/>
+                <a:cs typeface="Times New Roman" panose="02020603050405020304" pitchFamily="18" charset="0"/>
+              </a:rPr>
+              <a:t>[7] J. Malczewski, “GIS-based multicriteria decision analysis: a survey of the literature,” Int. J. Geographical Information Science, vol. 20, no. 7, pp. 703–726, 2006.</a:t>
+            </a:r>
+          </a:p>
+        </p:txBody>
+      </p:sp>
+    </p:spTree>
+    <p:extLst>
+      <p:ext uri="{BB962C8B-B14F-4D97-AF65-F5344CB8AC3E}">
+        <p14:creationId xmlns:p14="http://schemas.microsoft.com/office/powerpoint/2010/main" val="892815052"/>
+      </p:ext>
+    </p:extLst>
+  </p:cSld>
+  <p:clrMapOvr>
+    <a:masterClrMapping/>
+  </p:clrMapOvr>
+</p:sld>
+</file>
+
+<file path=ppt/slides/slide21.xml><?xml version="1.0" encoding="utf-8"?>
+<p:sld xmlns:a="http://schemas.openxmlformats.org/drawingml/2006/main" xmlns:r="http://schemas.openxmlformats.org/officeDocument/2006/relationships" xmlns:p="http://schemas.openxmlformats.org/presentationml/2006/main">
+  <p:cSld>
+    <p:spTree>
+      <p:nvGrpSpPr>
+        <p:cNvPr id="1" name="Shape 53">
+          <a:extLst>
+            <a:ext uri="{FF2B5EF4-FFF2-40B4-BE49-F238E27FC236}">
               <a16:creationId xmlns:a16="http://schemas.microsoft.com/office/drawing/2014/main" id="{BEEF7929-2959-90AA-2E93-1416F6432BF1}"/>
             </a:ext>
           </a:extLst>
@@ -14927,606 +15419,6 @@
 </p:sld>
 </file>
 
-<file path=ppt/slides/slide21.xml><?xml version="1.0" encoding="utf-8"?>
-<p:sld xmlns:a="http://schemas.openxmlformats.org/drawingml/2006/main" xmlns:r="http://schemas.openxmlformats.org/officeDocument/2006/relationships" xmlns:p="http://schemas.openxmlformats.org/presentationml/2006/main">
-  <p:cSld>
-    <p:spTree>
-      <p:nvGrpSpPr>
-        <p:cNvPr id="1" name="Shape 53">
-          <a:extLst>
-            <a:ext uri="{FF2B5EF4-FFF2-40B4-BE49-F238E27FC236}">
-              <a16:creationId xmlns:a16="http://schemas.microsoft.com/office/drawing/2014/main" id="{D249E2FF-7DD9-EC1B-AD92-B5825BFFFFA5}"/>
-            </a:ext>
-          </a:extLst>
-        </p:cNvPr>
-        <p:cNvGrpSpPr/>
-        <p:nvPr/>
-      </p:nvGrpSpPr>
-      <p:grpSpPr>
-        <a:xfrm>
-          <a:off x="0" y="0"/>
-          <a:ext cx="0" cy="0"/>
-          <a:chOff x="0" y="0"/>
-          <a:chExt cx="0" cy="0"/>
-        </a:xfrm>
-      </p:grpSpPr>
-      <p:sp>
-        <p:nvSpPr>
-          <p:cNvPr id="2" name="TextBox 1">
-            <a:extLst>
-              <a:ext uri="{FF2B5EF4-FFF2-40B4-BE49-F238E27FC236}">
-                <a16:creationId xmlns:a16="http://schemas.microsoft.com/office/drawing/2014/main" id="{B654F3DF-D776-9C44-4AB0-01A9D9E44D83}"/>
-              </a:ext>
-            </a:extLst>
-          </p:cNvPr>
-          <p:cNvSpPr txBox="1"/>
-          <p:nvPr/>
-        </p:nvSpPr>
-        <p:spPr>
-          <a:xfrm>
-            <a:off x="257175" y="4836100"/>
-            <a:ext cx="1343025" cy="276999"/>
-          </a:xfrm>
-          <a:prstGeom prst="rect">
-            <a:avLst/>
-          </a:prstGeom>
-          <a:noFill/>
-        </p:spPr>
-        <p:txBody>
-          <a:bodyPr wrap="square" rtlCol="0">
-            <a:spAutoFit/>
-          </a:bodyPr>
-          <a:lstStyle/>
-          <a:p>
-            <a:r>
-              <a:rPr lang="en-US" sz="1200" dirty="0">
-                <a:solidFill>
-                  <a:schemeClr val="bg1"/>
-                </a:solidFill>
-                <a:latin typeface="Times New Roman" panose="02020603050405020304" pitchFamily="18" charset="0"/>
-                <a:cs typeface="Times New Roman" panose="02020603050405020304" pitchFamily="18" charset="0"/>
-              </a:rPr>
-              <a:t>26/6/2023</a:t>
-            </a:r>
-          </a:p>
-        </p:txBody>
-      </p:sp>
-      <p:sp>
-        <p:nvSpPr>
-          <p:cNvPr id="15" name="Google Shape;97;p1">
-            <a:extLst>
-              <a:ext uri="{FF2B5EF4-FFF2-40B4-BE49-F238E27FC236}">
-                <a16:creationId xmlns:a16="http://schemas.microsoft.com/office/drawing/2014/main" id="{FE14819B-A2A4-F82D-EAEC-06D3F1AE8F22}"/>
-              </a:ext>
-            </a:extLst>
-          </p:cNvPr>
-          <p:cNvSpPr/>
-          <p:nvPr/>
-        </p:nvSpPr>
-        <p:spPr>
-          <a:xfrm>
-            <a:off x="8910006" y="1217600"/>
-            <a:ext cx="230488" cy="3941298"/>
-          </a:xfrm>
-          <a:prstGeom prst="rect">
-            <a:avLst/>
-          </a:prstGeom>
-          <a:solidFill>
-            <a:srgbClr val="C00000"/>
-          </a:solidFill>
-          <a:ln>
-            <a:noFill/>
-          </a:ln>
-        </p:spPr>
-        <p:txBody>
-          <a:bodyPr spcFirstLastPara="1" wrap="square" lIns="91425" tIns="45700" rIns="91425" bIns="45700" anchor="ctr" anchorCtr="0">
-            <a:noAutofit/>
-          </a:bodyPr>
-          <a:lstStyle/>
-          <a:p>
-            <a:pPr marL="0" marR="0" lvl="0" indent="0" algn="ctr" rtl="0">
-              <a:lnSpc>
-                <a:spcPct val="100000"/>
-              </a:lnSpc>
-              <a:spcBef>
-                <a:spcPts val="0"/>
-              </a:spcBef>
-              <a:spcAft>
-                <a:spcPts val="0"/>
-              </a:spcAft>
-              <a:buClr>
-                <a:srgbClr val="000000"/>
-              </a:buClr>
-              <a:buSzPts val="2493"/>
-              <a:buFont typeface="Arial"/>
-              <a:buNone/>
-            </a:pPr>
-            <a:endParaRPr sz="2493" b="0" i="0" u="none" strike="noStrike" cap="none">
-              <a:solidFill>
-                <a:schemeClr val="lt1"/>
-              </a:solidFill>
-              <a:latin typeface="Arial"/>
-              <a:ea typeface="Arial"/>
-              <a:cs typeface="Arial"/>
-              <a:sym typeface="Arial"/>
-            </a:endParaRPr>
-          </a:p>
-        </p:txBody>
-      </p:sp>
-      <p:sp>
-        <p:nvSpPr>
-          <p:cNvPr id="16" name="Google Shape;97;p1">
-            <a:extLst>
-              <a:ext uri="{FF2B5EF4-FFF2-40B4-BE49-F238E27FC236}">
-                <a16:creationId xmlns:a16="http://schemas.microsoft.com/office/drawing/2014/main" id="{AE4DCA9F-17A9-DFB5-CE57-FF3FEBFE31AD}"/>
-              </a:ext>
-            </a:extLst>
-          </p:cNvPr>
-          <p:cNvSpPr/>
-          <p:nvPr/>
-        </p:nvSpPr>
-        <p:spPr>
-          <a:xfrm>
-            <a:off x="2105025" y="4836100"/>
-            <a:ext cx="6807206" cy="322797"/>
-          </a:xfrm>
-          <a:prstGeom prst="rect">
-            <a:avLst/>
-          </a:prstGeom>
-          <a:solidFill>
-            <a:srgbClr val="C00000"/>
-          </a:solidFill>
-          <a:ln>
-            <a:noFill/>
-          </a:ln>
-        </p:spPr>
-        <p:txBody>
-          <a:bodyPr spcFirstLastPara="1" wrap="square" lIns="91425" tIns="45700" rIns="91425" bIns="45700" anchor="ctr" anchorCtr="0">
-            <a:noAutofit/>
-          </a:bodyPr>
-          <a:lstStyle/>
-          <a:p>
-            <a:pPr marL="0" marR="0" lvl="0" indent="0" algn="ctr" rtl="0">
-              <a:lnSpc>
-                <a:spcPct val="100000"/>
-              </a:lnSpc>
-              <a:spcBef>
-                <a:spcPts val="0"/>
-              </a:spcBef>
-              <a:spcAft>
-                <a:spcPts val="0"/>
-              </a:spcAft>
-              <a:buClr>
-                <a:srgbClr val="000000"/>
-              </a:buClr>
-              <a:buSzPts val="2493"/>
-              <a:buFont typeface="Arial"/>
-              <a:buNone/>
-            </a:pPr>
-            <a:endParaRPr sz="2493" b="0" i="0" u="none" strike="noStrike" cap="none">
-              <a:solidFill>
-                <a:schemeClr val="lt1"/>
-              </a:solidFill>
-              <a:latin typeface="Arial"/>
-              <a:ea typeface="Arial"/>
-              <a:cs typeface="Arial"/>
-              <a:sym typeface="Arial"/>
-            </a:endParaRPr>
-          </a:p>
-        </p:txBody>
-      </p:sp>
-      <p:sp>
-        <p:nvSpPr>
-          <p:cNvPr id="17" name="Rectangle 16">
-            <a:extLst>
-              <a:ext uri="{FF2B5EF4-FFF2-40B4-BE49-F238E27FC236}">
-                <a16:creationId xmlns:a16="http://schemas.microsoft.com/office/drawing/2014/main" id="{A2BA4D17-A024-D182-7185-0F2AA82B8EB1}"/>
-              </a:ext>
-            </a:extLst>
-          </p:cNvPr>
-          <p:cNvSpPr/>
-          <p:nvPr/>
-        </p:nvSpPr>
-        <p:spPr>
-          <a:xfrm>
-            <a:off x="0" y="4836100"/>
-            <a:ext cx="2105025" cy="322798"/>
-          </a:xfrm>
-          <a:prstGeom prst="rect">
-            <a:avLst/>
-          </a:prstGeom>
-          <a:solidFill>
-            <a:srgbClr val="FF0000"/>
-          </a:solidFill>
-          <a:ln>
-            <a:noFill/>
-          </a:ln>
-        </p:spPr>
-        <p:style>
-          <a:lnRef idx="2">
-            <a:schemeClr val="accent1">
-              <a:shade val="50000"/>
-            </a:schemeClr>
-          </a:lnRef>
-          <a:fillRef idx="1">
-            <a:schemeClr val="accent1"/>
-          </a:fillRef>
-          <a:effectRef idx="0">
-            <a:schemeClr val="accent1"/>
-          </a:effectRef>
-          <a:fontRef idx="minor">
-            <a:schemeClr val="lt1"/>
-          </a:fontRef>
-        </p:style>
-        <p:txBody>
-          <a:bodyPr rtlCol="0" anchor="ctr"/>
-          <a:lstStyle/>
-          <a:p>
-            <a:endParaRPr lang="en-US" sz="1200" dirty="0">
-              <a:latin typeface="Times New Roman" pitchFamily="18" charset="0"/>
-              <a:cs typeface="Times New Roman" pitchFamily="18" charset="0"/>
-            </a:endParaRPr>
-          </a:p>
-        </p:txBody>
-      </p:sp>
-      <p:pic>
-        <p:nvPicPr>
-          <p:cNvPr id="8" name="Picture 2">
-            <a:extLst>
-              <a:ext uri="{FF2B5EF4-FFF2-40B4-BE49-F238E27FC236}">
-                <a16:creationId xmlns:a16="http://schemas.microsoft.com/office/drawing/2014/main" id="{747ECE37-1D4A-CB6B-3EC5-211363DE71BC}"/>
-              </a:ext>
-            </a:extLst>
-          </p:cNvPr>
-          <p:cNvPicPr>
-            <a:picLocks noChangeAspect="1" noChangeArrowheads="1"/>
-          </p:cNvPicPr>
-          <p:nvPr/>
-        </p:nvPicPr>
-        <p:blipFill>
-          <a:blip r:embed="rId3">
-            <a:extLst>
-              <a:ext uri="{28A0092B-C50C-407E-A947-70E740481C1C}">
-                <a14:useLocalDpi xmlns:a14="http://schemas.microsoft.com/office/drawing/2010/main" val="0"/>
-              </a:ext>
-            </a:extLst>
-          </a:blip>
-          <a:srcRect/>
-          <a:stretch>
-            <a:fillRect/>
-          </a:stretch>
-        </p:blipFill>
-        <p:spPr bwMode="auto">
-          <a:xfrm>
-            <a:off x="0" y="0"/>
-            <a:ext cx="9140493" cy="1332186"/>
-          </a:xfrm>
-          <a:prstGeom prst="rect">
-            <a:avLst/>
-          </a:prstGeom>
-          <a:noFill/>
-          <a:ln>
-            <a:noFill/>
-          </a:ln>
-          <a:effectLst/>
-          <a:extLst>
-            <a:ext uri="{909E8E84-426E-40DD-AFC4-6F175D3DCCD1}">
-              <a14:hiddenFill xmlns:a14="http://schemas.microsoft.com/office/drawing/2010/main">
-                <a:solidFill>
-                  <a:schemeClr val="accent1"/>
-                </a:solidFill>
-              </a14:hiddenFill>
-            </a:ext>
-            <a:ext uri="{91240B29-F687-4F45-9708-019B960494DF}">
-              <a14:hiddenLine xmlns:a14="http://schemas.microsoft.com/office/drawing/2010/main" w="9525">
-                <a:solidFill>
-                  <a:schemeClr val="tx1"/>
-                </a:solidFill>
-                <a:miter lim="800000"/>
-                <a:headEnd/>
-                <a:tailEnd/>
-              </a14:hiddenLine>
-            </a:ext>
-            <a:ext uri="{AF507438-7753-43E0-B8FC-AC1667EBCBE1}">
-              <a14:hiddenEffects xmlns:a14="http://schemas.microsoft.com/office/drawing/2010/main">
-                <a:effectLst>
-                  <a:outerShdw dist="35921" dir="2700000" algn="ctr" rotWithShape="0">
-                    <a:schemeClr val="bg2"/>
-                  </a:outerShdw>
-                </a:effectLst>
-              </a14:hiddenEffects>
-            </a:ext>
-          </a:extLst>
-        </p:spPr>
-      </p:pic>
-      <p:sp>
-        <p:nvSpPr>
-          <p:cNvPr id="7" name="Google Shape;59;p13">
-            <a:extLst>
-              <a:ext uri="{FF2B5EF4-FFF2-40B4-BE49-F238E27FC236}">
-                <a16:creationId xmlns:a16="http://schemas.microsoft.com/office/drawing/2014/main" id="{A0D94E51-6F52-94FE-7C86-426F8587AFAC}"/>
-              </a:ext>
-            </a:extLst>
-          </p:cNvPr>
-          <p:cNvSpPr txBox="1"/>
-          <p:nvPr/>
-        </p:nvSpPr>
-        <p:spPr>
-          <a:xfrm>
-            <a:off x="61475" y="4508750"/>
-            <a:ext cx="8678700" cy="323135"/>
-          </a:xfrm>
-          <a:prstGeom prst="rect">
-            <a:avLst/>
-          </a:prstGeom>
-          <a:noFill/>
-          <a:ln>
-            <a:noFill/>
-          </a:ln>
-        </p:spPr>
-        <p:txBody>
-          <a:bodyPr spcFirstLastPara="1" wrap="square" lIns="91425" tIns="91425" rIns="91425" bIns="91425" anchor="t" anchorCtr="0">
-            <a:spAutoFit/>
-          </a:bodyPr>
-          <a:lstStyle/>
-          <a:p>
-            <a:pPr marL="0" lvl="0" indent="0" rtl="0">
-              <a:spcBef>
-                <a:spcPts val="0"/>
-              </a:spcBef>
-              <a:spcAft>
-                <a:spcPts val="0"/>
-              </a:spcAft>
-              <a:buNone/>
-            </a:pPr>
-            <a:r>
-              <a:rPr lang="en" sz="900" dirty="0">
-                <a:latin typeface="Times New Roman"/>
-                <a:ea typeface="Times New Roman"/>
-                <a:cs typeface="Times New Roman"/>
-                <a:sym typeface="Times New Roman"/>
-              </a:rPr>
-              <a:t>                                                                                                        </a:t>
-            </a:r>
-            <a:r>
-              <a:rPr lang="en" sz="900" i="1" dirty="0">
-                <a:latin typeface="Times New Roman"/>
-                <a:ea typeface="Times New Roman"/>
-                <a:cs typeface="Times New Roman"/>
-                <a:sym typeface="Times New Roman"/>
-              </a:rPr>
-              <a:t>Department of AI-DS, K J Somaiya Institute of Technology, Sion, Mumbai </a:t>
-            </a:r>
-            <a:endParaRPr sz="900" i="1" dirty="0">
-              <a:latin typeface="Times New Roman"/>
-              <a:ea typeface="Times New Roman"/>
-              <a:cs typeface="Times New Roman"/>
-              <a:sym typeface="Times New Roman"/>
-            </a:endParaRPr>
-          </a:p>
-        </p:txBody>
-      </p:sp>
-      <p:sp>
-        <p:nvSpPr>
-          <p:cNvPr id="11" name="Google Shape;62;p13">
-            <a:extLst>
-              <a:ext uri="{FF2B5EF4-FFF2-40B4-BE49-F238E27FC236}">
-                <a16:creationId xmlns:a16="http://schemas.microsoft.com/office/drawing/2014/main" id="{A4BD19CF-2634-830F-A672-136164E3A4ED}"/>
-              </a:ext>
-            </a:extLst>
-          </p:cNvPr>
-          <p:cNvSpPr txBox="1"/>
-          <p:nvPr/>
-        </p:nvSpPr>
-        <p:spPr>
-          <a:xfrm>
-            <a:off x="300000" y="1300000"/>
-            <a:ext cx="8500000" cy="420000"/>
-          </a:xfrm>
-          <a:prstGeom prst="rect">
-            <a:avLst/>
-          </a:prstGeom>
-          <a:noFill/>
-          <a:ln>
-            <a:noFill/>
-          </a:ln>
-        </p:spPr>
-        <p:txBody>
-          <a:bodyPr spcFirstLastPara="1" wrap="square" lIns="91425" tIns="45700" rIns="91425" bIns="45700" anchor="t" anchorCtr="0">
-            <a:spAutoFit/>
-          </a:bodyPr>
-          <a:lstStyle/>
-          <a:p>
-            <a:pPr marL="0" marR="0" lvl="0" indent="0" algn="l" rtl="0">
-              <a:spcBef>
-                <a:spcPts val="0"/>
-              </a:spcBef>
-              <a:spcAft>
-                <a:spcPts val="0"/>
-              </a:spcAft>
-              <a:buNone/>
-            </a:pPr>
-            <a:r>
-              <a:rPr lang="en-IN" sz="2000" b="1" dirty="0">
-                <a:solidFill>
-                  <a:srgbClr val="C00000"/>
-                </a:solidFill>
-                <a:latin typeface="Times New Roman"/>
-                <a:ea typeface="Times New Roman"/>
-                <a:cs typeface="Times New Roman"/>
-                <a:sym typeface="Times New Roman"/>
-              </a:rPr>
-              <a:t>How Our Project Overcomes the Research Gaps</a:t>
-            </a:r>
-            <a:endParaRPr sz="1800" dirty="0">
-              <a:solidFill>
-                <a:srgbClr val="000000"/>
-              </a:solidFill>
-              <a:latin typeface="Times New Roman"/>
-              <a:ea typeface="Times New Roman"/>
-              <a:cs typeface="Times New Roman"/>
-              <a:sym typeface="Times New Roman"/>
-            </a:endParaRPr>
-          </a:p>
-        </p:txBody>
-      </p:sp>
-      <p:sp>
-        <p:nvSpPr>
-          <p:cNvPr id="13" name="TextBox 12">
-            <a:extLst>
-              <a:ext uri="{FF2B5EF4-FFF2-40B4-BE49-F238E27FC236}">
-                <a16:creationId xmlns:a16="http://schemas.microsoft.com/office/drawing/2014/main" id="{D5299837-CD29-4FF5-BEE9-5C18315A4BC8}"/>
-              </a:ext>
-            </a:extLst>
-          </p:cNvPr>
-          <p:cNvSpPr txBox="1"/>
-          <p:nvPr/>
-        </p:nvSpPr>
-        <p:spPr>
-          <a:xfrm>
-            <a:off x="374386" y="1859048"/>
-            <a:ext cx="8535619" cy="2123658"/>
-          </a:xfrm>
-          <a:prstGeom prst="rect">
-            <a:avLst/>
-          </a:prstGeom>
-          <a:noFill/>
-        </p:spPr>
-        <p:txBody>
-          <a:bodyPr wrap="square">
-            <a:spAutoFit/>
-          </a:bodyPr>
-          <a:lstStyle/>
-          <a:p>
-            <a:pPr marL="285750" indent="-285750">
-              <a:spcAft>
-                <a:spcPts val="700"/>
-              </a:spcAft>
-              <a:buFont typeface="Arial" panose="020B0604020202020204" pitchFamily="34" charset="0"/>
-              <a:buChar char="•"/>
-            </a:pPr>
-            <a:r>
-              <a:rPr lang="en-US" sz="1200" b="1" dirty="0">
-                <a:latin typeface="Times New Roman" panose="02020603050405020304" pitchFamily="18" charset="0"/>
-                <a:cs typeface="Times New Roman" panose="02020603050405020304" pitchFamily="18" charset="0"/>
-              </a:rPr>
-              <a:t>Lack of logging and code testing (LLM-Geo): </a:t>
-            </a:r>
-            <a:r>
-              <a:rPr lang="en-US" sz="1200" dirty="0">
-                <a:latin typeface="Times New Roman" panose="02020603050405020304" pitchFamily="18" charset="0"/>
-                <a:cs typeface="Times New Roman" panose="02020603050405020304" pitchFamily="18" charset="0"/>
-              </a:rPr>
-              <a:t>every query is logged, and the generated SQL is validated before it runs on PostGIS, with the SQL and reasoning shown alongside the answer.</a:t>
-            </a:r>
-          </a:p>
-          <a:p>
-            <a:pPr marL="285750" indent="-285750">
-              <a:spcAft>
-                <a:spcPts val="700"/>
-              </a:spcAft>
-              <a:buFont typeface="Arial" panose="020B0604020202020204" pitchFamily="34" charset="0"/>
-              <a:buChar char="•"/>
-            </a:pPr>
-            <a:r>
-              <a:rPr lang="en-US" sz="1200" b="1" dirty="0">
-                <a:latin typeface="Times New Roman" panose="02020603050405020304" pitchFamily="18" charset="0"/>
-                <a:cs typeface="Times New Roman" panose="02020603050405020304" pitchFamily="18" charset="0"/>
-              </a:rPr>
-              <a:t>Geodesic vs. planar distance and aggregation errors (Spatial Text-to-SQL): </a:t>
-            </a:r>
-            <a:r>
-              <a:rPr lang="en-US" sz="1200" dirty="0">
-                <a:latin typeface="Times New Roman" panose="02020603050405020304" pitchFamily="18" charset="0"/>
-                <a:cs typeface="Times New Roman" panose="02020603050405020304" pitchFamily="18" charset="0"/>
-              </a:rPr>
-              <a:t>distances are computed in metres on the correct coordinate system, and results are checked through execution-based review before an answer is returned.</a:t>
-            </a:r>
-          </a:p>
-          <a:p>
-            <a:pPr marL="285750" indent="-285750">
-              <a:spcAft>
-                <a:spcPts val="700"/>
-              </a:spcAft>
-              <a:buFont typeface="Arial" panose="020B0604020202020204" pitchFamily="34" charset="0"/>
-              <a:buChar char="•"/>
-            </a:pPr>
-            <a:r>
-              <a:rPr lang="en-US" sz="1200" b="1" dirty="0">
-                <a:latin typeface="Times New Roman" panose="02020603050405020304" pitchFamily="18" charset="0"/>
-                <a:cs typeface="Times New Roman" panose="02020603050405020304" pitchFamily="18" charset="0"/>
-              </a:rPr>
-              <a:t>Dependence on predefined mapping rules (NALSpatial): </a:t>
-            </a:r>
-            <a:r>
-              <a:rPr lang="en-US" sz="1200" dirty="0">
-                <a:latin typeface="Times New Roman" panose="02020603050405020304" pitchFamily="18" charset="0"/>
-                <a:cs typeface="Times New Roman" panose="02020603050405020304" pitchFamily="18" charset="0"/>
-              </a:rPr>
-              <a:t>an LLM interprets intent with schema grounding, so open-ended business questions are handled without a fixed rule set or query categories.</a:t>
-            </a:r>
-          </a:p>
-          <a:p>
-            <a:pPr marL="285750" indent="-285750">
-              <a:spcAft>
-                <a:spcPts val="700"/>
-              </a:spcAft>
-              <a:buFont typeface="Arial" panose="020B0604020202020204" pitchFamily="34" charset="0"/>
-              <a:buChar char="•"/>
-            </a:pPr>
-            <a:r>
-              <a:rPr lang="en-US" sz="1200" b="1" dirty="0">
-                <a:latin typeface="Times New Roman" panose="02020603050405020304" pitchFamily="18" charset="0"/>
-                <a:cs typeface="Times New Roman" panose="02020603050405020304" pitchFamily="18" charset="0"/>
-              </a:rPr>
-              <a:t>Weak multi-entity spatial reasoning (GS-SQL): </a:t>
-            </a:r>
-            <a:r>
-              <a:rPr lang="en-US" sz="1200" dirty="0">
-                <a:latin typeface="Times New Roman" panose="02020603050405020304" pitchFamily="18" charset="0"/>
-                <a:cs typeface="Times New Roman" panose="02020603050405020304" pitchFamily="18" charset="0"/>
-              </a:rPr>
-              <a:t>complex requests such as "a cafe near a metro in a safe area" are broken into planned steps before SQL is generated.</a:t>
-            </a:r>
-          </a:p>
-          <a:p>
-            <a:pPr marL="285750" indent="-285750">
-              <a:spcAft>
-                <a:spcPts val="700"/>
-              </a:spcAft>
-              <a:buFont typeface="Arial" panose="020B0604020202020204" pitchFamily="34" charset="0"/>
-              <a:buChar char="•"/>
-            </a:pPr>
-            <a:r>
-              <a:rPr lang="en-US" sz="1200" b="1" dirty="0">
-                <a:latin typeface="Times New Roman" panose="02020603050405020304" pitchFamily="18" charset="0"/>
-                <a:cs typeface="Times New Roman" panose="02020603050405020304" pitchFamily="18" charset="0"/>
-              </a:rPr>
-              <a:t>Raw coordinates alone fail (GeoLLM): </a:t>
-            </a:r>
-            <a:r>
-              <a:rPr lang="en-US" sz="1200" dirty="0">
-                <a:latin typeface="Times New Roman" panose="02020603050405020304" pitchFamily="18" charset="0"/>
-                <a:cs typeface="Times New Roman" panose="02020603050405020304" pitchFamily="18" charset="0"/>
-              </a:rPr>
-              <a:t>answers are grounded in live Mumbai data (roads, POIs, real estate listings, crime and transit) rather than in the model's memory.</a:t>
-            </a:r>
-          </a:p>
-        </p:txBody>
-      </p:sp>
-    </p:spTree>
-    <p:extLst>
-      <p:ext uri="{BB962C8B-B14F-4D97-AF65-F5344CB8AC3E}">
-        <p14:creationId xmlns:p14="http://schemas.microsoft.com/office/powerpoint/2010/main" val="1528046246"/>
-      </p:ext>
-    </p:extLst>
-  </p:cSld>
-  <p:clrMapOvr>
-    <a:masterClrMapping/>
-  </p:clrMapOvr>
-</p:sld>
-</file>
-
 <file path=ppt/slides/slide3.xml><?xml version="1.0" encoding="utf-8"?>
 <p:sld xmlns:a="http://schemas.openxmlformats.org/drawingml/2006/main" xmlns:r="http://schemas.openxmlformats.org/officeDocument/2006/relationships" xmlns:p="http://schemas.openxmlformats.org/presentationml/2006/main">
   <p:cSld>
@@ -17938,8 +17830,8 @@
           <a:chExt cx="0" cy="0"/>
         </a:xfrm>
       </p:grpSpPr>
-      <mc:AlternateContent xmlns:mc="http://schemas.openxmlformats.org/markup-compatibility/2006">
-        <mc:Choice xmlns:a14="http://schemas.microsoft.com/office/drawing/2010/main" Requires="a14">
+      <mc:AlternateContent xmlns:mc="http://schemas.openxmlformats.org/markup-compatibility/2006" xmlns:a14="http://schemas.microsoft.com/office/drawing/2010/main">
+        <mc:Choice Requires="a14">
           <p:graphicFrame>
             <p:nvGraphicFramePr>
               <p:cNvPr id="3" name="Table 2">
@@ -20706,7 +20598,7 @@
             </a:graphic>
           </p:graphicFrame>
         </mc:Choice>
-        <mc:Fallback>
+        <mc:Fallback xmlns="">
           <p:graphicFrame>
             <p:nvGraphicFramePr>
               <p:cNvPr id="3" name="Table 2">
@@ -21310,7 +21202,7 @@
                               <a:effectLst/>
                               <a:latin typeface="Times New Roman" panose="02020603050405020304" pitchFamily="18" charset="0"/>
                               <a:cs typeface="Times New Roman" panose="02020603050405020304" pitchFamily="18" charset="0"/>
-                              <a:hlinkClick r:id="rId2"/>
+                              <a:hlinkClick r:id="rId7"/>
                             </a:rPr>
                             <a:t>T&amp;F: 10.1080/17538947.2023.2278895</a:t>
                           </a:r>
@@ -21732,7 +21624,7 @@
                               <a:effectLst/>
                               <a:latin typeface="Times New Roman" panose="02020603050405020304" pitchFamily="18" charset="0"/>
                               <a:cs typeface="Times New Roman" panose="02020603050405020304" pitchFamily="18" charset="0"/>
-                              <a:hlinkClick r:id="rId3"/>
+                              <a:hlinkClick r:id="rId8"/>
                             </a:rPr>
                             <a:t>arXiv</a:t>
                           </a:r>
@@ -21744,7 +21636,7 @@
                               <a:effectLst/>
                               <a:latin typeface="Times New Roman" panose="02020603050405020304" pitchFamily="18" charset="0"/>
                               <a:cs typeface="Times New Roman" panose="02020603050405020304" pitchFamily="18" charset="0"/>
-                              <a:hlinkClick r:id="rId3"/>
+                              <a:hlinkClick r:id="rId8"/>
                             </a:rPr>
                             <a:t>: 2510.21045</a:t>
                           </a:r>
@@ -22204,7 +22096,7 @@
                               <a:effectLst/>
                               <a:latin typeface="Times New Roman" panose="02020603050405020304" pitchFamily="18" charset="0"/>
                               <a:cs typeface="Times New Roman" panose="02020603050405020304" pitchFamily="18" charset="0"/>
-                              <a:hlinkClick r:id="rId4"/>
+                              <a:hlinkClick r:id="rId9"/>
                             </a:rPr>
                             <a:t>IEEE: 10824870</a:t>
                           </a:r>
@@ -22648,7 +22540,7 @@
                               <a:effectLst/>
                               <a:latin typeface="Times New Roman" panose="02020603050405020304" pitchFamily="18" charset="0"/>
                               <a:cs typeface="Times New Roman" panose="02020603050405020304" pitchFamily="18" charset="0"/>
-                              <a:hlinkClick r:id="rId5"/>
+                              <a:hlinkClick r:id="rId10"/>
                             </a:rPr>
                             <a:t>IEEE: 10651125</a:t>
                           </a:r>
@@ -23089,7 +22981,7 @@
                               <a:effectLst/>
                               <a:latin typeface="Times New Roman" panose="02020603050405020304" pitchFamily="18" charset="0"/>
                               <a:cs typeface="Times New Roman" panose="02020603050405020304" pitchFamily="18" charset="0"/>
-                              <a:hlinkClick r:id="rId6"/>
+                              <a:hlinkClick r:id="rId11"/>
                             </a:rPr>
                             <a:t>arXiv</a:t>
                           </a:r>
@@ -23101,7 +22993,7 @@
                               <a:effectLst/>
                               <a:latin typeface="Times New Roman" panose="02020603050405020304" pitchFamily="18" charset="0"/>
                               <a:cs typeface="Times New Roman" panose="02020603050405020304" pitchFamily="18" charset="0"/>
-                              <a:hlinkClick r:id="rId6"/>
+                              <a:hlinkClick r:id="rId11"/>
                             </a:rPr>
                             <a:t>: 2310.06213</a:t>
                           </a:r>
@@ -23340,7 +23232,7 @@
                           <a:tailEnd type="none" w="med" len="med"/>
                         </a:lnB>
                         <a:blipFill>
-                          <a:blip r:embed="rId7"/>
+                          <a:blip r:embed="rId12"/>
                           <a:stretch>
                             <a:fillRect l="-269375" t="-398851" r="-100312" b="-1149"/>
                           </a:stretch>
@@ -23437,6 +23329,606 @@
 </file>
 
 <file path=ppt/slides/slide6.xml><?xml version="1.0" encoding="utf-8"?>
+<p:sld xmlns:a="http://schemas.openxmlformats.org/drawingml/2006/main" xmlns:r="http://schemas.openxmlformats.org/officeDocument/2006/relationships" xmlns:p="http://schemas.openxmlformats.org/presentationml/2006/main">
+  <p:cSld>
+    <p:spTree>
+      <p:nvGrpSpPr>
+        <p:cNvPr id="1" name="Shape 53">
+          <a:extLst>
+            <a:ext uri="{FF2B5EF4-FFF2-40B4-BE49-F238E27FC236}">
+              <a16:creationId xmlns:a16="http://schemas.microsoft.com/office/drawing/2014/main" id="{D249E2FF-7DD9-EC1B-AD92-B5825BFFFFA5}"/>
+            </a:ext>
+          </a:extLst>
+        </p:cNvPr>
+        <p:cNvGrpSpPr/>
+        <p:nvPr/>
+      </p:nvGrpSpPr>
+      <p:grpSpPr>
+        <a:xfrm>
+          <a:off x="0" y="0"/>
+          <a:ext cx="0" cy="0"/>
+          <a:chOff x="0" y="0"/>
+          <a:chExt cx="0" cy="0"/>
+        </a:xfrm>
+      </p:grpSpPr>
+      <p:sp>
+        <p:nvSpPr>
+          <p:cNvPr id="2" name="TextBox 1">
+            <a:extLst>
+              <a:ext uri="{FF2B5EF4-FFF2-40B4-BE49-F238E27FC236}">
+                <a16:creationId xmlns:a16="http://schemas.microsoft.com/office/drawing/2014/main" id="{B654F3DF-D776-9C44-4AB0-01A9D9E44D83}"/>
+              </a:ext>
+            </a:extLst>
+          </p:cNvPr>
+          <p:cNvSpPr txBox="1"/>
+          <p:nvPr/>
+        </p:nvSpPr>
+        <p:spPr>
+          <a:xfrm>
+            <a:off x="257175" y="4836100"/>
+            <a:ext cx="1343025" cy="276999"/>
+          </a:xfrm>
+          <a:prstGeom prst="rect">
+            <a:avLst/>
+          </a:prstGeom>
+          <a:noFill/>
+        </p:spPr>
+        <p:txBody>
+          <a:bodyPr wrap="square" rtlCol="0">
+            <a:spAutoFit/>
+          </a:bodyPr>
+          <a:lstStyle/>
+          <a:p>
+            <a:r>
+              <a:rPr lang="en-US" sz="1200" dirty="0">
+                <a:solidFill>
+                  <a:schemeClr val="bg1"/>
+                </a:solidFill>
+                <a:latin typeface="Times New Roman" panose="02020603050405020304" pitchFamily="18" charset="0"/>
+                <a:cs typeface="Times New Roman" panose="02020603050405020304" pitchFamily="18" charset="0"/>
+              </a:rPr>
+              <a:t>26/6/2023</a:t>
+            </a:r>
+          </a:p>
+        </p:txBody>
+      </p:sp>
+      <p:sp>
+        <p:nvSpPr>
+          <p:cNvPr id="15" name="Google Shape;97;p1">
+            <a:extLst>
+              <a:ext uri="{FF2B5EF4-FFF2-40B4-BE49-F238E27FC236}">
+                <a16:creationId xmlns:a16="http://schemas.microsoft.com/office/drawing/2014/main" id="{FE14819B-A2A4-F82D-EAEC-06D3F1AE8F22}"/>
+              </a:ext>
+            </a:extLst>
+          </p:cNvPr>
+          <p:cNvSpPr/>
+          <p:nvPr/>
+        </p:nvSpPr>
+        <p:spPr>
+          <a:xfrm>
+            <a:off x="8910006" y="1217600"/>
+            <a:ext cx="230488" cy="3941298"/>
+          </a:xfrm>
+          <a:prstGeom prst="rect">
+            <a:avLst/>
+          </a:prstGeom>
+          <a:solidFill>
+            <a:srgbClr val="C00000"/>
+          </a:solidFill>
+          <a:ln>
+            <a:noFill/>
+          </a:ln>
+        </p:spPr>
+        <p:txBody>
+          <a:bodyPr spcFirstLastPara="1" wrap="square" lIns="91425" tIns="45700" rIns="91425" bIns="45700" anchor="ctr" anchorCtr="0">
+            <a:noAutofit/>
+          </a:bodyPr>
+          <a:lstStyle/>
+          <a:p>
+            <a:pPr marL="0" marR="0" lvl="0" indent="0" algn="ctr" rtl="0">
+              <a:lnSpc>
+                <a:spcPct val="100000"/>
+              </a:lnSpc>
+              <a:spcBef>
+                <a:spcPts val="0"/>
+              </a:spcBef>
+              <a:spcAft>
+                <a:spcPts val="0"/>
+              </a:spcAft>
+              <a:buClr>
+                <a:srgbClr val="000000"/>
+              </a:buClr>
+              <a:buSzPts val="2493"/>
+              <a:buFont typeface="Arial"/>
+              <a:buNone/>
+            </a:pPr>
+            <a:endParaRPr sz="2493" b="0" i="0" u="none" strike="noStrike" cap="none">
+              <a:solidFill>
+                <a:schemeClr val="lt1"/>
+              </a:solidFill>
+              <a:latin typeface="Arial"/>
+              <a:ea typeface="Arial"/>
+              <a:cs typeface="Arial"/>
+              <a:sym typeface="Arial"/>
+            </a:endParaRPr>
+          </a:p>
+        </p:txBody>
+      </p:sp>
+      <p:sp>
+        <p:nvSpPr>
+          <p:cNvPr id="16" name="Google Shape;97;p1">
+            <a:extLst>
+              <a:ext uri="{FF2B5EF4-FFF2-40B4-BE49-F238E27FC236}">
+                <a16:creationId xmlns:a16="http://schemas.microsoft.com/office/drawing/2014/main" id="{AE4DCA9F-17A9-DFB5-CE57-FF3FEBFE31AD}"/>
+              </a:ext>
+            </a:extLst>
+          </p:cNvPr>
+          <p:cNvSpPr/>
+          <p:nvPr/>
+        </p:nvSpPr>
+        <p:spPr>
+          <a:xfrm>
+            <a:off x="2105025" y="4836100"/>
+            <a:ext cx="6807206" cy="322797"/>
+          </a:xfrm>
+          <a:prstGeom prst="rect">
+            <a:avLst/>
+          </a:prstGeom>
+          <a:solidFill>
+            <a:srgbClr val="C00000"/>
+          </a:solidFill>
+          <a:ln>
+            <a:noFill/>
+          </a:ln>
+        </p:spPr>
+        <p:txBody>
+          <a:bodyPr spcFirstLastPara="1" wrap="square" lIns="91425" tIns="45700" rIns="91425" bIns="45700" anchor="ctr" anchorCtr="0">
+            <a:noAutofit/>
+          </a:bodyPr>
+          <a:lstStyle/>
+          <a:p>
+            <a:pPr marL="0" marR="0" lvl="0" indent="0" algn="ctr" rtl="0">
+              <a:lnSpc>
+                <a:spcPct val="100000"/>
+              </a:lnSpc>
+              <a:spcBef>
+                <a:spcPts val="0"/>
+              </a:spcBef>
+              <a:spcAft>
+                <a:spcPts val="0"/>
+              </a:spcAft>
+              <a:buClr>
+                <a:srgbClr val="000000"/>
+              </a:buClr>
+              <a:buSzPts val="2493"/>
+              <a:buFont typeface="Arial"/>
+              <a:buNone/>
+            </a:pPr>
+            <a:endParaRPr sz="2493" b="0" i="0" u="none" strike="noStrike" cap="none">
+              <a:solidFill>
+                <a:schemeClr val="lt1"/>
+              </a:solidFill>
+              <a:latin typeface="Arial"/>
+              <a:ea typeface="Arial"/>
+              <a:cs typeface="Arial"/>
+              <a:sym typeface="Arial"/>
+            </a:endParaRPr>
+          </a:p>
+        </p:txBody>
+      </p:sp>
+      <p:sp>
+        <p:nvSpPr>
+          <p:cNvPr id="17" name="Rectangle 16">
+            <a:extLst>
+              <a:ext uri="{FF2B5EF4-FFF2-40B4-BE49-F238E27FC236}">
+                <a16:creationId xmlns:a16="http://schemas.microsoft.com/office/drawing/2014/main" id="{A2BA4D17-A024-D182-7185-0F2AA82B8EB1}"/>
+              </a:ext>
+            </a:extLst>
+          </p:cNvPr>
+          <p:cNvSpPr/>
+          <p:nvPr/>
+        </p:nvSpPr>
+        <p:spPr>
+          <a:xfrm>
+            <a:off x="0" y="4836100"/>
+            <a:ext cx="2105025" cy="322798"/>
+          </a:xfrm>
+          <a:prstGeom prst="rect">
+            <a:avLst/>
+          </a:prstGeom>
+          <a:solidFill>
+            <a:srgbClr val="FF0000"/>
+          </a:solidFill>
+          <a:ln>
+            <a:noFill/>
+          </a:ln>
+        </p:spPr>
+        <p:style>
+          <a:lnRef idx="2">
+            <a:schemeClr val="accent1">
+              <a:shade val="50000"/>
+            </a:schemeClr>
+          </a:lnRef>
+          <a:fillRef idx="1">
+            <a:schemeClr val="accent1"/>
+          </a:fillRef>
+          <a:effectRef idx="0">
+            <a:schemeClr val="accent1"/>
+          </a:effectRef>
+          <a:fontRef idx="minor">
+            <a:schemeClr val="lt1"/>
+          </a:fontRef>
+        </p:style>
+        <p:txBody>
+          <a:bodyPr rtlCol="0" anchor="ctr"/>
+          <a:lstStyle/>
+          <a:p>
+            <a:endParaRPr lang="en-US" sz="1200" dirty="0">
+              <a:latin typeface="Times New Roman" pitchFamily="18" charset="0"/>
+              <a:cs typeface="Times New Roman" pitchFamily="18" charset="0"/>
+            </a:endParaRPr>
+          </a:p>
+        </p:txBody>
+      </p:sp>
+      <p:pic>
+        <p:nvPicPr>
+          <p:cNvPr id="8" name="Picture 2">
+            <a:extLst>
+              <a:ext uri="{FF2B5EF4-FFF2-40B4-BE49-F238E27FC236}">
+                <a16:creationId xmlns:a16="http://schemas.microsoft.com/office/drawing/2014/main" id="{747ECE37-1D4A-CB6B-3EC5-211363DE71BC}"/>
+              </a:ext>
+            </a:extLst>
+          </p:cNvPr>
+          <p:cNvPicPr>
+            <a:picLocks noChangeAspect="1" noChangeArrowheads="1"/>
+          </p:cNvPicPr>
+          <p:nvPr/>
+        </p:nvPicPr>
+        <p:blipFill>
+          <a:blip r:embed="rId2">
+            <a:extLst>
+              <a:ext uri="{28A0092B-C50C-407E-A947-70E740481C1C}">
+                <a14:useLocalDpi xmlns:a14="http://schemas.microsoft.com/office/drawing/2010/main" val="0"/>
+              </a:ext>
+            </a:extLst>
+          </a:blip>
+          <a:srcRect/>
+          <a:stretch>
+            <a:fillRect/>
+          </a:stretch>
+        </p:blipFill>
+        <p:spPr bwMode="auto">
+          <a:xfrm>
+            <a:off x="0" y="0"/>
+            <a:ext cx="9140493" cy="1332186"/>
+          </a:xfrm>
+          <a:prstGeom prst="rect">
+            <a:avLst/>
+          </a:prstGeom>
+          <a:noFill/>
+          <a:ln>
+            <a:noFill/>
+          </a:ln>
+          <a:effectLst/>
+          <a:extLst>
+            <a:ext uri="{909E8E84-426E-40DD-AFC4-6F175D3DCCD1}">
+              <a14:hiddenFill xmlns:a14="http://schemas.microsoft.com/office/drawing/2010/main">
+                <a:solidFill>
+                  <a:schemeClr val="accent1"/>
+                </a:solidFill>
+              </a14:hiddenFill>
+            </a:ext>
+            <a:ext uri="{91240B29-F687-4F45-9708-019B960494DF}">
+              <a14:hiddenLine xmlns:a14="http://schemas.microsoft.com/office/drawing/2010/main" w="9525">
+                <a:solidFill>
+                  <a:schemeClr val="tx1"/>
+                </a:solidFill>
+                <a:miter lim="800000"/>
+                <a:headEnd/>
+                <a:tailEnd/>
+              </a14:hiddenLine>
+            </a:ext>
+            <a:ext uri="{AF507438-7753-43E0-B8FC-AC1667EBCBE1}">
+              <a14:hiddenEffects xmlns:a14="http://schemas.microsoft.com/office/drawing/2010/main">
+                <a:effectLst>
+                  <a:outerShdw dist="35921" dir="2700000" algn="ctr" rotWithShape="0">
+                    <a:schemeClr val="bg2"/>
+                  </a:outerShdw>
+                </a:effectLst>
+              </a14:hiddenEffects>
+            </a:ext>
+          </a:extLst>
+        </p:spPr>
+      </p:pic>
+      <p:sp>
+        <p:nvSpPr>
+          <p:cNvPr id="7" name="Google Shape;59;p13">
+            <a:extLst>
+              <a:ext uri="{FF2B5EF4-FFF2-40B4-BE49-F238E27FC236}">
+                <a16:creationId xmlns:a16="http://schemas.microsoft.com/office/drawing/2014/main" id="{A0D94E51-6F52-94FE-7C86-426F8587AFAC}"/>
+              </a:ext>
+            </a:extLst>
+          </p:cNvPr>
+          <p:cNvSpPr txBox="1"/>
+          <p:nvPr/>
+        </p:nvSpPr>
+        <p:spPr>
+          <a:xfrm>
+            <a:off x="61475" y="4508750"/>
+            <a:ext cx="8678700" cy="323135"/>
+          </a:xfrm>
+          <a:prstGeom prst="rect">
+            <a:avLst/>
+          </a:prstGeom>
+          <a:noFill/>
+          <a:ln>
+            <a:noFill/>
+          </a:ln>
+        </p:spPr>
+        <p:txBody>
+          <a:bodyPr spcFirstLastPara="1" wrap="square" lIns="91425" tIns="91425" rIns="91425" bIns="91425" anchor="t" anchorCtr="0">
+            <a:spAutoFit/>
+          </a:bodyPr>
+          <a:lstStyle/>
+          <a:p>
+            <a:pPr marL="0" lvl="0" indent="0" rtl="0">
+              <a:spcBef>
+                <a:spcPts val="0"/>
+              </a:spcBef>
+              <a:spcAft>
+                <a:spcPts val="0"/>
+              </a:spcAft>
+              <a:buNone/>
+            </a:pPr>
+            <a:r>
+              <a:rPr lang="en" sz="900" dirty="0">
+                <a:latin typeface="Times New Roman"/>
+                <a:ea typeface="Times New Roman"/>
+                <a:cs typeface="Times New Roman"/>
+                <a:sym typeface="Times New Roman"/>
+              </a:rPr>
+              <a:t>                                                                                                        </a:t>
+            </a:r>
+            <a:r>
+              <a:rPr lang="en" sz="900" i="1" dirty="0">
+                <a:latin typeface="Times New Roman"/>
+                <a:ea typeface="Times New Roman"/>
+                <a:cs typeface="Times New Roman"/>
+                <a:sym typeface="Times New Roman"/>
+              </a:rPr>
+              <a:t>Department of AI-DS, K J Somaiya Institute of Technology, Sion, Mumbai </a:t>
+            </a:r>
+            <a:endParaRPr sz="900" i="1" dirty="0">
+              <a:latin typeface="Times New Roman"/>
+              <a:ea typeface="Times New Roman"/>
+              <a:cs typeface="Times New Roman"/>
+              <a:sym typeface="Times New Roman"/>
+            </a:endParaRPr>
+          </a:p>
+        </p:txBody>
+      </p:sp>
+      <p:sp>
+        <p:nvSpPr>
+          <p:cNvPr id="11" name="Google Shape;62;p13">
+            <a:extLst>
+              <a:ext uri="{FF2B5EF4-FFF2-40B4-BE49-F238E27FC236}">
+                <a16:creationId xmlns:a16="http://schemas.microsoft.com/office/drawing/2014/main" id="{A4BD19CF-2634-830F-A672-136164E3A4ED}"/>
+              </a:ext>
+            </a:extLst>
+          </p:cNvPr>
+          <p:cNvSpPr txBox="1"/>
+          <p:nvPr/>
+        </p:nvSpPr>
+        <p:spPr>
+          <a:xfrm>
+            <a:off x="300000" y="1300000"/>
+            <a:ext cx="8500000" cy="400069"/>
+          </a:xfrm>
+          <a:prstGeom prst="rect">
+            <a:avLst/>
+          </a:prstGeom>
+          <a:noFill/>
+          <a:ln>
+            <a:noFill/>
+          </a:ln>
+        </p:spPr>
+        <p:txBody>
+          <a:bodyPr spcFirstLastPara="1" wrap="square" lIns="91425" tIns="45700" rIns="91425" bIns="45700" anchor="t" anchorCtr="0">
+            <a:spAutoFit/>
+          </a:bodyPr>
+          <a:lstStyle/>
+          <a:p>
+            <a:pPr marL="0" marR="0" lvl="0" indent="0" algn="l" rtl="0">
+              <a:spcBef>
+                <a:spcPts val="0"/>
+              </a:spcBef>
+              <a:spcAft>
+                <a:spcPts val="0"/>
+              </a:spcAft>
+              <a:buNone/>
+            </a:pPr>
+            <a:r>
+              <a:rPr lang="en-IN" sz="2000" b="1" dirty="0">
+                <a:solidFill>
+                  <a:srgbClr val="C00000"/>
+                </a:solidFill>
+                <a:latin typeface="Times New Roman"/>
+                <a:ea typeface="Times New Roman"/>
+                <a:cs typeface="Times New Roman"/>
+                <a:sym typeface="Times New Roman"/>
+              </a:rPr>
+              <a:t>How Our Project Addresses the Research Gaps</a:t>
+            </a:r>
+            <a:endParaRPr sz="1800" dirty="0">
+              <a:solidFill>
+                <a:srgbClr val="000000"/>
+              </a:solidFill>
+              <a:latin typeface="Times New Roman"/>
+              <a:ea typeface="Times New Roman"/>
+              <a:cs typeface="Times New Roman"/>
+              <a:sym typeface="Times New Roman"/>
+            </a:endParaRPr>
+          </a:p>
+        </p:txBody>
+      </p:sp>
+      <p:sp>
+        <p:nvSpPr>
+          <p:cNvPr id="13" name="TextBox 12">
+            <a:extLst>
+              <a:ext uri="{FF2B5EF4-FFF2-40B4-BE49-F238E27FC236}">
+                <a16:creationId xmlns:a16="http://schemas.microsoft.com/office/drawing/2014/main" id="{D5299837-CD29-4FF5-BEE9-5C18315A4BC8}"/>
+              </a:ext>
+            </a:extLst>
+          </p:cNvPr>
+          <p:cNvSpPr txBox="1"/>
+          <p:nvPr/>
+        </p:nvSpPr>
+        <p:spPr>
+          <a:xfrm>
+            <a:off x="374386" y="1859048"/>
+            <a:ext cx="8535619" cy="2123658"/>
+          </a:xfrm>
+          <a:prstGeom prst="rect">
+            <a:avLst/>
+          </a:prstGeom>
+          <a:noFill/>
+        </p:spPr>
+        <p:txBody>
+          <a:bodyPr wrap="square">
+            <a:spAutoFit/>
+          </a:bodyPr>
+          <a:lstStyle/>
+          <a:p>
+            <a:pPr marL="285750" indent="-285750">
+              <a:spcAft>
+                <a:spcPts val="700"/>
+              </a:spcAft>
+              <a:buFont typeface="Arial" panose="020B0604020202020204" pitchFamily="34" charset="0"/>
+              <a:buChar char="•"/>
+            </a:pPr>
+            <a:r>
+              <a:rPr lang="en-US" sz="1200" b="1" dirty="0">
+                <a:latin typeface="Times New Roman" panose="02020603050405020304" pitchFamily="18" charset="0"/>
+                <a:cs typeface="Times New Roman" panose="02020603050405020304" pitchFamily="18" charset="0"/>
+              </a:rPr>
+              <a:t>Lack of logging and code testing (LLM-Geo): </a:t>
+            </a:r>
+            <a:r>
+              <a:rPr lang="en-US" sz="1200" dirty="0">
+                <a:latin typeface="Times New Roman" panose="02020603050405020304" pitchFamily="18" charset="0"/>
+                <a:cs typeface="Times New Roman" panose="02020603050405020304" pitchFamily="18" charset="0"/>
+              </a:rPr>
+              <a:t>every query is logged, and the generated SQL is validated before it runs on PostGIS, with the SQL and reasoning shown alongside the answer.</a:t>
+            </a:r>
+          </a:p>
+          <a:p>
+            <a:pPr marL="285750" indent="-285750">
+              <a:spcAft>
+                <a:spcPts val="700"/>
+              </a:spcAft>
+              <a:buFont typeface="Arial" panose="020B0604020202020204" pitchFamily="34" charset="0"/>
+              <a:buChar char="•"/>
+            </a:pPr>
+            <a:r>
+              <a:rPr lang="en-US" sz="1200" b="1" dirty="0">
+                <a:latin typeface="Times New Roman" panose="02020603050405020304" pitchFamily="18" charset="0"/>
+                <a:cs typeface="Times New Roman" panose="02020603050405020304" pitchFamily="18" charset="0"/>
+              </a:rPr>
+              <a:t>Geodesic vs. planar distance and aggregation errors (Spatial Text-to-SQL): </a:t>
+            </a:r>
+            <a:r>
+              <a:rPr lang="en-US" sz="1200" dirty="0">
+                <a:latin typeface="Times New Roman" panose="02020603050405020304" pitchFamily="18" charset="0"/>
+                <a:cs typeface="Times New Roman" panose="02020603050405020304" pitchFamily="18" charset="0"/>
+              </a:rPr>
+              <a:t>distances are computed in metres on the correct coordinate system, and results are checked through execution-based review before an answer is returned.</a:t>
+            </a:r>
+          </a:p>
+          <a:p>
+            <a:pPr marL="285750" indent="-285750">
+              <a:spcAft>
+                <a:spcPts val="700"/>
+              </a:spcAft>
+              <a:buFont typeface="Arial" panose="020B0604020202020204" pitchFamily="34" charset="0"/>
+              <a:buChar char="•"/>
+            </a:pPr>
+            <a:r>
+              <a:rPr lang="en-US" sz="1200" b="1" dirty="0">
+                <a:latin typeface="Times New Roman" panose="02020603050405020304" pitchFamily="18" charset="0"/>
+                <a:cs typeface="Times New Roman" panose="02020603050405020304" pitchFamily="18" charset="0"/>
+              </a:rPr>
+              <a:t>Dependence on predefined mapping rules (NALSpatial): </a:t>
+            </a:r>
+            <a:r>
+              <a:rPr lang="en-US" sz="1200" dirty="0">
+                <a:latin typeface="Times New Roman" panose="02020603050405020304" pitchFamily="18" charset="0"/>
+                <a:cs typeface="Times New Roman" panose="02020603050405020304" pitchFamily="18" charset="0"/>
+              </a:rPr>
+              <a:t>an LLM interprets intent with schema grounding, so open-ended business questions are handled without a fixed rule set or query categories.</a:t>
+            </a:r>
+          </a:p>
+          <a:p>
+            <a:pPr marL="285750" indent="-285750">
+              <a:spcAft>
+                <a:spcPts val="700"/>
+              </a:spcAft>
+              <a:buFont typeface="Arial" panose="020B0604020202020204" pitchFamily="34" charset="0"/>
+              <a:buChar char="•"/>
+            </a:pPr>
+            <a:r>
+              <a:rPr lang="en-US" sz="1200" b="1" dirty="0">
+                <a:latin typeface="Times New Roman" panose="02020603050405020304" pitchFamily="18" charset="0"/>
+                <a:cs typeface="Times New Roman" panose="02020603050405020304" pitchFamily="18" charset="0"/>
+              </a:rPr>
+              <a:t>Weak multi-entity spatial reasoning (GS-SQL): </a:t>
+            </a:r>
+            <a:r>
+              <a:rPr lang="en-US" sz="1200" dirty="0">
+                <a:latin typeface="Times New Roman" panose="02020603050405020304" pitchFamily="18" charset="0"/>
+                <a:cs typeface="Times New Roman" panose="02020603050405020304" pitchFamily="18" charset="0"/>
+              </a:rPr>
+              <a:t>complex requests such as "a cafe near a metro in a safe area" are broken into planned steps before SQL is generated.</a:t>
+            </a:r>
+          </a:p>
+          <a:p>
+            <a:pPr marL="285750" indent="-285750">
+              <a:spcAft>
+                <a:spcPts val="700"/>
+              </a:spcAft>
+              <a:buFont typeface="Arial" panose="020B0604020202020204" pitchFamily="34" charset="0"/>
+              <a:buChar char="•"/>
+            </a:pPr>
+            <a:r>
+              <a:rPr lang="en-US" sz="1200" b="1" dirty="0">
+                <a:latin typeface="Times New Roman" panose="02020603050405020304" pitchFamily="18" charset="0"/>
+                <a:cs typeface="Times New Roman" panose="02020603050405020304" pitchFamily="18" charset="0"/>
+              </a:rPr>
+              <a:t>Raw coordinates alone fail (GeoLLM): </a:t>
+            </a:r>
+            <a:r>
+              <a:rPr lang="en-US" sz="1200" dirty="0">
+                <a:latin typeface="Times New Roman" panose="02020603050405020304" pitchFamily="18" charset="0"/>
+                <a:cs typeface="Times New Roman" panose="02020603050405020304" pitchFamily="18" charset="0"/>
+              </a:rPr>
+              <a:t>answers are grounded in live Mumbai data (roads, POIs, real estate listings, crime and transit) rather than in the model's memory.</a:t>
+            </a:r>
+          </a:p>
+        </p:txBody>
+      </p:sp>
+    </p:spTree>
+    <p:extLst>
+      <p:ext uri="{BB962C8B-B14F-4D97-AF65-F5344CB8AC3E}">
+        <p14:creationId xmlns:p14="http://schemas.microsoft.com/office/powerpoint/2010/main" val="1528046246"/>
+      </p:ext>
+    </p:extLst>
+  </p:cSld>
+  <p:clrMapOvr>
+    <a:masterClrMapping/>
+  </p:clrMapOvr>
+</p:sld>
+</file>
+
+<file path=ppt/slides/slide7.xml><?xml version="1.0" encoding="utf-8"?>
 <p:sld xmlns:a="http://schemas.openxmlformats.org/drawingml/2006/main" xmlns:r="http://schemas.openxmlformats.org/officeDocument/2006/relationships" xmlns:p="http://schemas.openxmlformats.org/presentationml/2006/main">
   <p:cSld>
     <p:spTree>
@@ -23923,7 +24415,7 @@
 </p:sld>
 </file>
 
-<file path=ppt/slides/slide7.xml><?xml version="1.0" encoding="utf-8"?>
+<file path=ppt/slides/slide8.xml><?xml version="1.0" encoding="utf-8"?>
 <p:sld xmlns:a="http://schemas.openxmlformats.org/drawingml/2006/main" xmlns:r="http://schemas.openxmlformats.org/officeDocument/2006/relationships" xmlns:p="http://schemas.openxmlformats.org/presentationml/2006/main">
   <p:cSld>
     <p:spTree>
@@ -24490,7 +24982,7 @@
 </p:sld>
 </file>
 
-<file path=ppt/slides/slide8.xml><?xml version="1.0" encoding="utf-8"?>
+<file path=ppt/slides/slide9.xml><?xml version="1.0" encoding="utf-8"?>
 <p:sld xmlns:a="http://schemas.openxmlformats.org/drawingml/2006/main" xmlns:r="http://schemas.openxmlformats.org/officeDocument/2006/relationships" xmlns:p="http://schemas.openxmlformats.org/presentationml/2006/main">
   <p:cSld>
     <p:spTree>
@@ -24970,498 +25462,6 @@
     <p:extLst>
       <p:ext uri="{BB962C8B-B14F-4D97-AF65-F5344CB8AC3E}">
         <p14:creationId xmlns:p14="http://schemas.microsoft.com/office/powerpoint/2010/main" val="2609091291"/>
-      </p:ext>
-    </p:extLst>
-  </p:cSld>
-  <p:clrMapOvr>
-    <a:masterClrMapping/>
-  </p:clrMapOvr>
-</p:sld>
-</file>
-
-<file path=ppt/slides/slide9.xml><?xml version="1.0" encoding="utf-8"?>
-<p:sld xmlns:a="http://schemas.openxmlformats.org/drawingml/2006/main" xmlns:r="http://schemas.openxmlformats.org/officeDocument/2006/relationships" xmlns:p="http://schemas.openxmlformats.org/presentationml/2006/main">
-  <p:cSld>
-    <p:spTree>
-      <p:nvGrpSpPr>
-        <p:cNvPr id="1" name="Shape 53">
-          <a:extLst>
-            <a:ext uri="{FF2B5EF4-FFF2-40B4-BE49-F238E27FC236}">
-              <a16:creationId xmlns:a16="http://schemas.microsoft.com/office/drawing/2014/main" id="{9AC9D310-4864-5590-01EC-E271D4772333}"/>
-            </a:ext>
-          </a:extLst>
-        </p:cNvPr>
-        <p:cNvGrpSpPr/>
-        <p:nvPr/>
-      </p:nvGrpSpPr>
-      <p:grpSpPr>
-        <a:xfrm>
-          <a:off x="0" y="0"/>
-          <a:ext cx="0" cy="0"/>
-          <a:chOff x="0" y="0"/>
-          <a:chExt cx="0" cy="0"/>
-        </a:xfrm>
-      </p:grpSpPr>
-      <p:sp>
-        <p:nvSpPr>
-          <p:cNvPr id="2" name="TextBox 1">
-            <a:extLst>
-              <a:ext uri="{FF2B5EF4-FFF2-40B4-BE49-F238E27FC236}">
-                <a16:creationId xmlns:a16="http://schemas.microsoft.com/office/drawing/2014/main" id="{2486D6B1-412D-B9E1-2B60-E93887B2BB76}"/>
-              </a:ext>
-            </a:extLst>
-          </p:cNvPr>
-          <p:cNvSpPr txBox="1"/>
-          <p:nvPr/>
-        </p:nvSpPr>
-        <p:spPr>
-          <a:xfrm>
-            <a:off x="257175" y="4836100"/>
-            <a:ext cx="1343025" cy="276999"/>
-          </a:xfrm>
-          <a:prstGeom prst="rect">
-            <a:avLst/>
-          </a:prstGeom>
-          <a:noFill/>
-        </p:spPr>
-        <p:txBody>
-          <a:bodyPr wrap="square" rtlCol="0">
-            <a:spAutoFit/>
-          </a:bodyPr>
-          <a:lstStyle/>
-          <a:p>
-            <a:r>
-              <a:rPr lang="en-US" sz="1200" dirty="0">
-                <a:solidFill>
-                  <a:schemeClr val="bg1"/>
-                </a:solidFill>
-                <a:latin typeface="Times New Roman" panose="02020603050405020304" pitchFamily="18" charset="0"/>
-                <a:cs typeface="Times New Roman" panose="02020603050405020304" pitchFamily="18" charset="0"/>
-              </a:rPr>
-              <a:t>26/6/2023</a:t>
-            </a:r>
-          </a:p>
-        </p:txBody>
-      </p:sp>
-      <p:sp>
-        <p:nvSpPr>
-          <p:cNvPr id="15" name="Google Shape;97;p1">
-            <a:extLst>
-              <a:ext uri="{FF2B5EF4-FFF2-40B4-BE49-F238E27FC236}">
-                <a16:creationId xmlns:a16="http://schemas.microsoft.com/office/drawing/2014/main" id="{E47EBBBB-2103-581C-62AE-3A6C94A9BB61}"/>
-              </a:ext>
-            </a:extLst>
-          </p:cNvPr>
-          <p:cNvSpPr/>
-          <p:nvPr/>
-        </p:nvSpPr>
-        <p:spPr>
-          <a:xfrm>
-            <a:off x="8910006" y="1217600"/>
-            <a:ext cx="230488" cy="3941298"/>
-          </a:xfrm>
-          <a:prstGeom prst="rect">
-            <a:avLst/>
-          </a:prstGeom>
-          <a:solidFill>
-            <a:srgbClr val="C00000"/>
-          </a:solidFill>
-          <a:ln>
-            <a:noFill/>
-          </a:ln>
-        </p:spPr>
-        <p:txBody>
-          <a:bodyPr spcFirstLastPara="1" wrap="square" lIns="91425" tIns="45700" rIns="91425" bIns="45700" anchor="ctr" anchorCtr="0">
-            <a:noAutofit/>
-          </a:bodyPr>
-          <a:lstStyle/>
-          <a:p>
-            <a:pPr marL="0" marR="0" lvl="0" indent="0" algn="ctr" rtl="0">
-              <a:lnSpc>
-                <a:spcPct val="100000"/>
-              </a:lnSpc>
-              <a:spcBef>
-                <a:spcPts val="0"/>
-              </a:spcBef>
-              <a:spcAft>
-                <a:spcPts val="0"/>
-              </a:spcAft>
-              <a:buClr>
-                <a:srgbClr val="000000"/>
-              </a:buClr>
-              <a:buSzPts val="2493"/>
-              <a:buFont typeface="Arial"/>
-              <a:buNone/>
-            </a:pPr>
-            <a:endParaRPr sz="2493" b="0" i="0" u="none" strike="noStrike" cap="none">
-              <a:solidFill>
-                <a:schemeClr val="lt1"/>
-              </a:solidFill>
-              <a:latin typeface="Arial"/>
-              <a:ea typeface="Arial"/>
-              <a:cs typeface="Arial"/>
-              <a:sym typeface="Arial"/>
-            </a:endParaRPr>
-          </a:p>
-        </p:txBody>
-      </p:sp>
-      <p:sp>
-        <p:nvSpPr>
-          <p:cNvPr id="16" name="Google Shape;97;p1">
-            <a:extLst>
-              <a:ext uri="{FF2B5EF4-FFF2-40B4-BE49-F238E27FC236}">
-                <a16:creationId xmlns:a16="http://schemas.microsoft.com/office/drawing/2014/main" id="{4A189411-E6B6-3AD2-F9D7-14323DAF38C3}"/>
-              </a:ext>
-            </a:extLst>
-          </p:cNvPr>
-          <p:cNvSpPr/>
-          <p:nvPr/>
-        </p:nvSpPr>
-        <p:spPr>
-          <a:xfrm>
-            <a:off x="2105025" y="4836100"/>
-            <a:ext cx="6807206" cy="322797"/>
-          </a:xfrm>
-          <a:prstGeom prst="rect">
-            <a:avLst/>
-          </a:prstGeom>
-          <a:solidFill>
-            <a:srgbClr val="C00000"/>
-          </a:solidFill>
-          <a:ln>
-            <a:noFill/>
-          </a:ln>
-        </p:spPr>
-        <p:txBody>
-          <a:bodyPr spcFirstLastPara="1" wrap="square" lIns="91425" tIns="45700" rIns="91425" bIns="45700" anchor="ctr" anchorCtr="0">
-            <a:noAutofit/>
-          </a:bodyPr>
-          <a:lstStyle/>
-          <a:p>
-            <a:pPr marL="0" marR="0" lvl="0" indent="0" algn="ctr" rtl="0">
-              <a:lnSpc>
-                <a:spcPct val="100000"/>
-              </a:lnSpc>
-              <a:spcBef>
-                <a:spcPts val="0"/>
-              </a:spcBef>
-              <a:spcAft>
-                <a:spcPts val="0"/>
-              </a:spcAft>
-              <a:buClr>
-                <a:srgbClr val="000000"/>
-              </a:buClr>
-              <a:buSzPts val="2493"/>
-              <a:buFont typeface="Arial"/>
-              <a:buNone/>
-            </a:pPr>
-            <a:endParaRPr sz="2493" b="0" i="0" u="none" strike="noStrike" cap="none">
-              <a:solidFill>
-                <a:schemeClr val="lt1"/>
-              </a:solidFill>
-              <a:latin typeface="Arial"/>
-              <a:ea typeface="Arial"/>
-              <a:cs typeface="Arial"/>
-              <a:sym typeface="Arial"/>
-            </a:endParaRPr>
-          </a:p>
-        </p:txBody>
-      </p:sp>
-      <p:sp>
-        <p:nvSpPr>
-          <p:cNvPr id="17" name="Rectangle 16">
-            <a:extLst>
-              <a:ext uri="{FF2B5EF4-FFF2-40B4-BE49-F238E27FC236}">
-                <a16:creationId xmlns:a16="http://schemas.microsoft.com/office/drawing/2014/main" id="{2B64D24D-6253-C5A7-684B-84D557D646E1}"/>
-              </a:ext>
-            </a:extLst>
-          </p:cNvPr>
-          <p:cNvSpPr/>
-          <p:nvPr/>
-        </p:nvSpPr>
-        <p:spPr>
-          <a:xfrm>
-            <a:off x="0" y="4836100"/>
-            <a:ext cx="2105025" cy="322798"/>
-          </a:xfrm>
-          <a:prstGeom prst="rect">
-            <a:avLst/>
-          </a:prstGeom>
-          <a:solidFill>
-            <a:srgbClr val="FF0000"/>
-          </a:solidFill>
-          <a:ln>
-            <a:noFill/>
-          </a:ln>
-        </p:spPr>
-        <p:style>
-          <a:lnRef idx="2">
-            <a:schemeClr val="accent1">
-              <a:shade val="50000"/>
-            </a:schemeClr>
-          </a:lnRef>
-          <a:fillRef idx="1">
-            <a:schemeClr val="accent1"/>
-          </a:fillRef>
-          <a:effectRef idx="0">
-            <a:schemeClr val="accent1"/>
-          </a:effectRef>
-          <a:fontRef idx="minor">
-            <a:schemeClr val="lt1"/>
-          </a:fontRef>
-        </p:style>
-        <p:txBody>
-          <a:bodyPr rtlCol="0" anchor="ctr"/>
-          <a:lstStyle/>
-          <a:p>
-            <a:endParaRPr lang="en-US" sz="1200" dirty="0">
-              <a:latin typeface="Times New Roman" pitchFamily="18" charset="0"/>
-              <a:cs typeface="Times New Roman" pitchFamily="18" charset="0"/>
-            </a:endParaRPr>
-          </a:p>
-        </p:txBody>
-      </p:sp>
-      <p:pic>
-        <p:nvPicPr>
-          <p:cNvPr id="8" name="Picture 2">
-            <a:extLst>
-              <a:ext uri="{FF2B5EF4-FFF2-40B4-BE49-F238E27FC236}">
-                <a16:creationId xmlns:a16="http://schemas.microsoft.com/office/drawing/2014/main" id="{0F8827DB-DDB0-6DA0-5EBE-F1CDA01C8DAE}"/>
-              </a:ext>
-            </a:extLst>
-          </p:cNvPr>
-          <p:cNvPicPr>
-            <a:picLocks noChangeAspect="1" noChangeArrowheads="1"/>
-          </p:cNvPicPr>
-          <p:nvPr/>
-        </p:nvPicPr>
-        <p:blipFill>
-          <a:blip r:embed="rId3">
-            <a:extLst>
-              <a:ext uri="{28A0092B-C50C-407E-A947-70E740481C1C}">
-                <a14:useLocalDpi xmlns:a14="http://schemas.microsoft.com/office/drawing/2010/main" val="0"/>
-              </a:ext>
-            </a:extLst>
-          </a:blip>
-          <a:srcRect/>
-          <a:stretch>
-            <a:fillRect/>
-          </a:stretch>
-        </p:blipFill>
-        <p:spPr bwMode="auto">
-          <a:xfrm>
-            <a:off x="0" y="0"/>
-            <a:ext cx="9140493" cy="1332186"/>
-          </a:xfrm>
-          <a:prstGeom prst="rect">
-            <a:avLst/>
-          </a:prstGeom>
-          <a:noFill/>
-          <a:ln>
-            <a:noFill/>
-          </a:ln>
-          <a:effectLst/>
-          <a:extLst>
-            <a:ext uri="{909E8E84-426E-40DD-AFC4-6F175D3DCCD1}">
-              <a14:hiddenFill xmlns:a14="http://schemas.microsoft.com/office/drawing/2010/main">
-                <a:solidFill>
-                  <a:schemeClr val="accent1"/>
-                </a:solidFill>
-              </a14:hiddenFill>
-            </a:ext>
-            <a:ext uri="{91240B29-F687-4F45-9708-019B960494DF}">
-              <a14:hiddenLine xmlns:a14="http://schemas.microsoft.com/office/drawing/2010/main" w="9525">
-                <a:solidFill>
-                  <a:schemeClr val="tx1"/>
-                </a:solidFill>
-                <a:miter lim="800000"/>
-                <a:headEnd/>
-                <a:tailEnd/>
-              </a14:hiddenLine>
-            </a:ext>
-            <a:ext uri="{AF507438-7753-43E0-B8FC-AC1667EBCBE1}">
-              <a14:hiddenEffects xmlns:a14="http://schemas.microsoft.com/office/drawing/2010/main">
-                <a:effectLst>
-                  <a:outerShdw dist="35921" dir="2700000" algn="ctr" rotWithShape="0">
-                    <a:schemeClr val="bg2"/>
-                  </a:outerShdw>
-                </a:effectLst>
-              </a14:hiddenEffects>
-            </a:ext>
-          </a:extLst>
-        </p:spPr>
-      </p:pic>
-      <p:sp>
-        <p:nvSpPr>
-          <p:cNvPr id="7" name="Google Shape;59;p13">
-            <a:extLst>
-              <a:ext uri="{FF2B5EF4-FFF2-40B4-BE49-F238E27FC236}">
-                <a16:creationId xmlns:a16="http://schemas.microsoft.com/office/drawing/2014/main" id="{86719920-E6A2-6F3A-5ED0-756DB9F14FA5}"/>
-              </a:ext>
-            </a:extLst>
-          </p:cNvPr>
-          <p:cNvSpPr txBox="1"/>
-          <p:nvPr/>
-        </p:nvSpPr>
-        <p:spPr>
-          <a:xfrm>
-            <a:off x="61475" y="4508750"/>
-            <a:ext cx="8678700" cy="323135"/>
-          </a:xfrm>
-          <a:prstGeom prst="rect">
-            <a:avLst/>
-          </a:prstGeom>
-          <a:noFill/>
-          <a:ln>
-            <a:noFill/>
-          </a:ln>
-        </p:spPr>
-        <p:txBody>
-          <a:bodyPr spcFirstLastPara="1" wrap="square" lIns="91425" tIns="91425" rIns="91425" bIns="91425" anchor="t" anchorCtr="0">
-            <a:spAutoFit/>
-          </a:bodyPr>
-          <a:lstStyle/>
-          <a:p>
-            <a:pPr marL="0" lvl="0" indent="0" rtl="0">
-              <a:spcBef>
-                <a:spcPts val="0"/>
-              </a:spcBef>
-              <a:spcAft>
-                <a:spcPts val="0"/>
-              </a:spcAft>
-              <a:buNone/>
-            </a:pPr>
-            <a:r>
-              <a:rPr lang="en" sz="900" dirty="0">
-                <a:latin typeface="Times New Roman"/>
-                <a:ea typeface="Times New Roman"/>
-                <a:cs typeface="Times New Roman"/>
-                <a:sym typeface="Times New Roman"/>
-              </a:rPr>
-              <a:t>                                                                                                        </a:t>
-            </a:r>
-            <a:r>
-              <a:rPr lang="en" sz="900" i="1" dirty="0">
-                <a:latin typeface="Times New Roman"/>
-                <a:ea typeface="Times New Roman"/>
-                <a:cs typeface="Times New Roman"/>
-                <a:sym typeface="Times New Roman"/>
-              </a:rPr>
-              <a:t>Department of AI-DS, K J Somaiya Institute of Technology, Sion, Mumbai </a:t>
-            </a:r>
-            <a:endParaRPr sz="900" i="1" dirty="0">
-              <a:latin typeface="Times New Roman"/>
-              <a:ea typeface="Times New Roman"/>
-              <a:cs typeface="Times New Roman"/>
-              <a:sym typeface="Times New Roman"/>
-            </a:endParaRPr>
-          </a:p>
-        </p:txBody>
-      </p:sp>
-      <p:sp>
-        <p:nvSpPr>
-          <p:cNvPr id="5" name="Google Shape;62;p13">
-            <a:extLst>
-              <a:ext uri="{FF2B5EF4-FFF2-40B4-BE49-F238E27FC236}">
-                <a16:creationId xmlns:a16="http://schemas.microsoft.com/office/drawing/2014/main" id="{4F3B70C8-3900-6C02-0754-2639E651B4B2}"/>
-              </a:ext>
-            </a:extLst>
-          </p:cNvPr>
-          <p:cNvSpPr txBox="1"/>
-          <p:nvPr/>
-        </p:nvSpPr>
-        <p:spPr>
-          <a:xfrm>
-            <a:off x="300000" y="1300000"/>
-            <a:ext cx="8500000" cy="420000"/>
-          </a:xfrm>
-          <a:prstGeom prst="rect">
-            <a:avLst/>
-          </a:prstGeom>
-          <a:noFill/>
-          <a:ln>
-            <a:noFill/>
-          </a:ln>
-        </p:spPr>
-        <p:txBody>
-          <a:bodyPr spcFirstLastPara="1" wrap="square" lIns="91425" tIns="45700" rIns="91425" bIns="45700" anchor="t" anchorCtr="0">
-            <a:spAutoFit/>
-          </a:bodyPr>
-          <a:lstStyle/>
-          <a:p>
-            <a:pPr marL="0" marR="0" lvl="0" indent="0" algn="l" rtl="0">
-              <a:spcBef>
-                <a:spcPts val="0"/>
-              </a:spcBef>
-              <a:spcAft>
-                <a:spcPts val="0"/>
-              </a:spcAft>
-              <a:buNone/>
-            </a:pPr>
-            <a:r>
-              <a:rPr lang="en-IN" sz="2000" b="1" dirty="0">
-                <a:solidFill>
-                  <a:srgbClr val="C00000"/>
-                </a:solidFill>
-                <a:latin typeface="Times New Roman"/>
-                <a:ea typeface="Times New Roman"/>
-                <a:cs typeface="Times New Roman"/>
-                <a:sym typeface="Times New Roman"/>
-              </a:rPr>
-              <a:t>Proposed System Implementation</a:t>
-            </a:r>
-            <a:endParaRPr sz="1800" dirty="0">
-              <a:solidFill>
-                <a:srgbClr val="000000"/>
-              </a:solidFill>
-              <a:latin typeface="Times New Roman"/>
-              <a:ea typeface="Times New Roman"/>
-              <a:cs typeface="Times New Roman"/>
-              <a:sym typeface="Times New Roman"/>
-            </a:endParaRPr>
-          </a:p>
-        </p:txBody>
-      </p:sp>
-      <p:pic>
-        <p:nvPicPr>
-          <p:cNvPr id="9" name="Graphic 8">
-            <a:extLst>
-              <a:ext uri="{FF2B5EF4-FFF2-40B4-BE49-F238E27FC236}">
-                <a16:creationId xmlns:a16="http://schemas.microsoft.com/office/drawing/2014/main" id="{6BEE846D-440B-1C8A-C0EF-EAD5518C6FF7}"/>
-              </a:ext>
-            </a:extLst>
-          </p:cNvPr>
-          <p:cNvPicPr>
-            <a:picLocks noChangeAspect="1"/>
-          </p:cNvPicPr>
-          <p:nvPr/>
-        </p:nvPicPr>
-        <p:blipFill>
-          <a:blip>
-            <a:extLst>
-              <a:ext uri="{96DAC541-7B7A-43D3-8B79-37D633B846F1}">
-                <asvg:svgBlip xmlns:asvg="http://schemas.microsoft.com/office/drawing/2016/SVG/main" r:embed="rId4"/>
-              </a:ext>
-            </a:extLst>
-          </a:blip>
-          <a:stretch>
-            <a:fillRect/>
-          </a:stretch>
-        </p:blipFill>
-        <p:spPr>
-          <a:xfrm>
-            <a:off x="300000" y="1799689"/>
-            <a:ext cx="8379901" cy="2113284"/>
-          </a:xfrm>
-          <a:prstGeom prst="rect">
-            <a:avLst/>
-          </a:prstGeom>
-        </p:spPr>
-      </p:pic>
-    </p:spTree>
-    <p:extLst>
-      <p:ext uri="{BB962C8B-B14F-4D97-AF65-F5344CB8AC3E}">
-        <p14:creationId xmlns:p14="http://schemas.microsoft.com/office/powerpoint/2010/main" val="565558269"/>
       </p:ext>
     </p:extLst>
   </p:cSld>

</xml_diff>